<commit_message>
Updated .gitignore to exclude data files
</commit_message>
<xml_diff>
--- a/agent-diagrams.pptx
+++ b/agent-diagrams.pptx
@@ -254,7 +254,7 @@
           <a:p>
             <a:fld id="{7EFC964A-A7A6-4716-9273-3B457FACE4DE}" type="datetimeFigureOut">
               <a:rPr lang="en-US" smtClean="0"/>
-              <a:t>2/2/2026</a:t>
+              <a:t>3/13/2026</a:t>
             </a:fld>
             <a:endParaRPr lang="en-US"/>
           </a:p>
@@ -424,7 +424,7 @@
           <a:p>
             <a:fld id="{7EFC964A-A7A6-4716-9273-3B457FACE4DE}" type="datetimeFigureOut">
               <a:rPr lang="en-US" smtClean="0"/>
-              <a:t>2/2/2026</a:t>
+              <a:t>3/13/2026</a:t>
             </a:fld>
             <a:endParaRPr lang="en-US"/>
           </a:p>
@@ -604,7 +604,7 @@
           <a:p>
             <a:fld id="{7EFC964A-A7A6-4716-9273-3B457FACE4DE}" type="datetimeFigureOut">
               <a:rPr lang="en-US" smtClean="0"/>
-              <a:t>2/2/2026</a:t>
+              <a:t>3/13/2026</a:t>
             </a:fld>
             <a:endParaRPr lang="en-US"/>
           </a:p>
@@ -774,7 +774,7 @@
           <a:p>
             <a:fld id="{7EFC964A-A7A6-4716-9273-3B457FACE4DE}" type="datetimeFigureOut">
               <a:rPr lang="en-US" smtClean="0"/>
-              <a:t>2/2/2026</a:t>
+              <a:t>3/13/2026</a:t>
             </a:fld>
             <a:endParaRPr lang="en-US"/>
           </a:p>
@@ -1020,7 +1020,7 @@
           <a:p>
             <a:fld id="{7EFC964A-A7A6-4716-9273-3B457FACE4DE}" type="datetimeFigureOut">
               <a:rPr lang="en-US" smtClean="0"/>
-              <a:t>2/2/2026</a:t>
+              <a:t>3/13/2026</a:t>
             </a:fld>
             <a:endParaRPr lang="en-US"/>
           </a:p>
@@ -1252,7 +1252,7 @@
           <a:p>
             <a:fld id="{7EFC964A-A7A6-4716-9273-3B457FACE4DE}" type="datetimeFigureOut">
               <a:rPr lang="en-US" smtClean="0"/>
-              <a:t>2/2/2026</a:t>
+              <a:t>3/13/2026</a:t>
             </a:fld>
             <a:endParaRPr lang="en-US"/>
           </a:p>
@@ -1619,7 +1619,7 @@
           <a:p>
             <a:fld id="{7EFC964A-A7A6-4716-9273-3B457FACE4DE}" type="datetimeFigureOut">
               <a:rPr lang="en-US" smtClean="0"/>
-              <a:t>2/2/2026</a:t>
+              <a:t>3/13/2026</a:t>
             </a:fld>
             <a:endParaRPr lang="en-US"/>
           </a:p>
@@ -1737,7 +1737,7 @@
           <a:p>
             <a:fld id="{7EFC964A-A7A6-4716-9273-3B457FACE4DE}" type="datetimeFigureOut">
               <a:rPr lang="en-US" smtClean="0"/>
-              <a:t>2/2/2026</a:t>
+              <a:t>3/13/2026</a:t>
             </a:fld>
             <a:endParaRPr lang="en-US"/>
           </a:p>
@@ -1832,7 +1832,7 @@
           <a:p>
             <a:fld id="{7EFC964A-A7A6-4716-9273-3B457FACE4DE}" type="datetimeFigureOut">
               <a:rPr lang="en-US" smtClean="0"/>
-              <a:t>2/2/2026</a:t>
+              <a:t>3/13/2026</a:t>
             </a:fld>
             <a:endParaRPr lang="en-US"/>
           </a:p>
@@ -2109,7 +2109,7 @@
           <a:p>
             <a:fld id="{7EFC964A-A7A6-4716-9273-3B457FACE4DE}" type="datetimeFigureOut">
               <a:rPr lang="en-US" smtClean="0"/>
-              <a:t>2/2/2026</a:t>
+              <a:t>3/13/2026</a:t>
             </a:fld>
             <a:endParaRPr lang="en-US"/>
           </a:p>
@@ -2366,7 +2366,7 @@
           <a:p>
             <a:fld id="{7EFC964A-A7A6-4716-9273-3B457FACE4DE}" type="datetimeFigureOut">
               <a:rPr lang="en-US" smtClean="0"/>
-              <a:t>2/2/2026</a:t>
+              <a:t>3/13/2026</a:t>
             </a:fld>
             <a:endParaRPr lang="en-US"/>
           </a:p>
@@ -2579,7 +2579,7 @@
           <a:p>
             <a:fld id="{7EFC964A-A7A6-4716-9273-3B457FACE4DE}" type="datetimeFigureOut">
               <a:rPr lang="en-US" smtClean="0"/>
-              <a:t>2/2/2026</a:t>
+              <a:t>3/13/2026</a:t>
             </a:fld>
             <a:endParaRPr lang="en-US"/>
           </a:p>
@@ -3090,61 +3090,6 @@
       </p:sp>
       <p:sp>
         <p:nvSpPr>
-          <p:cNvPr id="7" name="Rectangle: Rounded Corners 6">
-            <a:extLst>
-              <a:ext uri="{FF2B5EF4-FFF2-40B4-BE49-F238E27FC236}">
-                <a16:creationId xmlns:a16="http://schemas.microsoft.com/office/drawing/2014/main" id="{B8B06C48-C959-6EDC-63DB-4A0D49387DD5}"/>
-              </a:ext>
-            </a:extLst>
-          </p:cNvPr>
-          <p:cNvSpPr/>
-          <p:nvPr/>
-        </p:nvSpPr>
-        <p:spPr>
-          <a:xfrm>
-            <a:off x="1323467" y="1612232"/>
-            <a:ext cx="1371600" cy="914400"/>
-          </a:xfrm>
-          <a:prstGeom prst="roundRect">
-            <a:avLst/>
-          </a:prstGeom>
-          <a:solidFill>
-            <a:schemeClr val="accent5"/>
-          </a:solidFill>
-          <a:ln>
-            <a:noFill/>
-          </a:ln>
-        </p:spPr>
-        <p:style>
-          <a:lnRef idx="2">
-            <a:schemeClr val="accent1">
-              <a:shade val="15000"/>
-            </a:schemeClr>
-          </a:lnRef>
-          <a:fillRef idx="1">
-            <a:schemeClr val="accent1"/>
-          </a:fillRef>
-          <a:effectRef idx="0">
-            <a:schemeClr val="accent1"/>
-          </a:effectRef>
-          <a:fontRef idx="minor">
-            <a:schemeClr val="lt1"/>
-          </a:fontRef>
-        </p:style>
-        <p:txBody>
-          <a:bodyPr rtlCol="0" anchor="ctr"/>
-          <a:lstStyle/>
-          <a:p>
-            <a:pPr algn="ctr"/>
-            <a:r>
-              <a:rPr lang="en-US" sz="1600" dirty="0"/>
-              <a:t>Tasker</a:t>
-            </a:r>
-          </a:p>
-        </p:txBody>
-      </p:sp>
-      <p:sp>
-        <p:nvSpPr>
           <p:cNvPr id="5" name="Rectangle: Rounded Corners 4">
             <a:extLst>
               <a:ext uri="{FF2B5EF4-FFF2-40B4-BE49-F238E27FC236}">
@@ -3327,7 +3272,7 @@
             <a:avLst/>
           </a:prstGeom>
           <a:solidFill>
-            <a:schemeClr val="accent6"/>
+            <a:schemeClr val="accent5"/>
           </a:solidFill>
           <a:ln>
             <a:noFill/>
@@ -3437,7 +3382,7 @@
             <a:avLst/>
           </a:prstGeom>
           <a:solidFill>
-            <a:schemeClr val="accent6"/>
+            <a:schemeClr val="accent5"/>
           </a:solidFill>
           <a:ln>
             <a:noFill/>
@@ -3763,21 +3708,19 @@
           </p:cNvPr>
           <p:cNvCxnSpPr>
             <a:cxnSpLocks/>
-            <a:stCxn id="7" idx="3"/>
+            <a:stCxn id="18" idx="3"/>
             <a:endCxn id="62" idx="1"/>
           </p:cNvCxnSpPr>
           <p:nvPr/>
         </p:nvCxnSpPr>
         <p:spPr>
-          <a:xfrm flipH="1">
-            <a:off x="1323467" y="2069432"/>
-            <a:ext cx="1371600" cy="1118937"/>
-          </a:xfrm>
-          <a:prstGeom prst="bentConnector5">
+          <a:xfrm>
+            <a:off x="1108906" y="2069432"/>
+            <a:ext cx="214561" cy="1118937"/>
+          </a:xfrm>
+          <a:prstGeom prst="bentConnector3">
             <a:avLst>
-              <a:gd name="adj1" fmla="val -16667"/>
-              <a:gd name="adj2" fmla="val 65188"/>
-              <a:gd name="adj3" fmla="val 116667"/>
+              <a:gd name="adj1" fmla="val 50000"/>
             </a:avLst>
           </a:prstGeom>
           <a:ln>

</xml_diff>

<commit_message>
Added marginal (step-wise) token counting
</commit_message>
<xml_diff>
--- a/agent-diagrams.pptx
+++ b/agent-diagrams.pptx
@@ -254,7 +254,7 @@
           <a:p>
             <a:fld id="{7EFC964A-A7A6-4716-9273-3B457FACE4DE}" type="datetimeFigureOut">
               <a:rPr lang="en-US" smtClean="0"/>
-              <a:t>3/13/2026</a:t>
+              <a:t>4/4/2026</a:t>
             </a:fld>
             <a:endParaRPr lang="en-US"/>
           </a:p>
@@ -424,7 +424,7 @@
           <a:p>
             <a:fld id="{7EFC964A-A7A6-4716-9273-3B457FACE4DE}" type="datetimeFigureOut">
               <a:rPr lang="en-US" smtClean="0"/>
-              <a:t>3/13/2026</a:t>
+              <a:t>4/4/2026</a:t>
             </a:fld>
             <a:endParaRPr lang="en-US"/>
           </a:p>
@@ -604,7 +604,7 @@
           <a:p>
             <a:fld id="{7EFC964A-A7A6-4716-9273-3B457FACE4DE}" type="datetimeFigureOut">
               <a:rPr lang="en-US" smtClean="0"/>
-              <a:t>3/13/2026</a:t>
+              <a:t>4/4/2026</a:t>
             </a:fld>
             <a:endParaRPr lang="en-US"/>
           </a:p>
@@ -774,7 +774,7 @@
           <a:p>
             <a:fld id="{7EFC964A-A7A6-4716-9273-3B457FACE4DE}" type="datetimeFigureOut">
               <a:rPr lang="en-US" smtClean="0"/>
-              <a:t>3/13/2026</a:t>
+              <a:t>4/4/2026</a:t>
             </a:fld>
             <a:endParaRPr lang="en-US"/>
           </a:p>
@@ -1020,7 +1020,7 @@
           <a:p>
             <a:fld id="{7EFC964A-A7A6-4716-9273-3B457FACE4DE}" type="datetimeFigureOut">
               <a:rPr lang="en-US" smtClean="0"/>
-              <a:t>3/13/2026</a:t>
+              <a:t>4/4/2026</a:t>
             </a:fld>
             <a:endParaRPr lang="en-US"/>
           </a:p>
@@ -1252,7 +1252,7 @@
           <a:p>
             <a:fld id="{7EFC964A-A7A6-4716-9273-3B457FACE4DE}" type="datetimeFigureOut">
               <a:rPr lang="en-US" smtClean="0"/>
-              <a:t>3/13/2026</a:t>
+              <a:t>4/4/2026</a:t>
             </a:fld>
             <a:endParaRPr lang="en-US"/>
           </a:p>
@@ -1619,7 +1619,7 @@
           <a:p>
             <a:fld id="{7EFC964A-A7A6-4716-9273-3B457FACE4DE}" type="datetimeFigureOut">
               <a:rPr lang="en-US" smtClean="0"/>
-              <a:t>3/13/2026</a:t>
+              <a:t>4/4/2026</a:t>
             </a:fld>
             <a:endParaRPr lang="en-US"/>
           </a:p>
@@ -1737,7 +1737,7 @@
           <a:p>
             <a:fld id="{7EFC964A-A7A6-4716-9273-3B457FACE4DE}" type="datetimeFigureOut">
               <a:rPr lang="en-US" smtClean="0"/>
-              <a:t>3/13/2026</a:t>
+              <a:t>4/4/2026</a:t>
             </a:fld>
             <a:endParaRPr lang="en-US"/>
           </a:p>
@@ -1832,7 +1832,7 @@
           <a:p>
             <a:fld id="{7EFC964A-A7A6-4716-9273-3B457FACE4DE}" type="datetimeFigureOut">
               <a:rPr lang="en-US" smtClean="0"/>
-              <a:t>3/13/2026</a:t>
+              <a:t>4/4/2026</a:t>
             </a:fld>
             <a:endParaRPr lang="en-US"/>
           </a:p>
@@ -2109,7 +2109,7 @@
           <a:p>
             <a:fld id="{7EFC964A-A7A6-4716-9273-3B457FACE4DE}" type="datetimeFigureOut">
               <a:rPr lang="en-US" smtClean="0"/>
-              <a:t>3/13/2026</a:t>
+              <a:t>4/4/2026</a:t>
             </a:fld>
             <a:endParaRPr lang="en-US"/>
           </a:p>
@@ -2366,7 +2366,7 @@
           <a:p>
             <a:fld id="{7EFC964A-A7A6-4716-9273-3B457FACE4DE}" type="datetimeFigureOut">
               <a:rPr lang="en-US" smtClean="0"/>
-              <a:t>3/13/2026</a:t>
+              <a:t>4/4/2026</a:t>
             </a:fld>
             <a:endParaRPr lang="en-US"/>
           </a:p>
@@ -2579,7 +2579,7 @@
           <a:p>
             <a:fld id="{7EFC964A-A7A6-4716-9273-3B457FACE4DE}" type="datetimeFigureOut">
               <a:rPr lang="en-US" smtClean="0"/>
-              <a:t>3/13/2026</a:t>
+              <a:t>4/4/2026</a:t>
             </a:fld>
             <a:endParaRPr lang="en-US"/>
           </a:p>
@@ -2986,10 +2986,44 @@
       </p:grpSpPr>
       <p:sp>
         <p:nvSpPr>
-          <p:cNvPr id="62" name="Rectangle: Rounded Corners 61">
+          <p:cNvPr id="4" name="Title 1">
             <a:extLst>
               <a:ext uri="{FF2B5EF4-FFF2-40B4-BE49-F238E27FC236}">
-                <a16:creationId xmlns:a16="http://schemas.microsoft.com/office/drawing/2014/main" id="{537F5CB7-A763-799A-3F57-A2CC336FA171}"/>
+                <a16:creationId xmlns:a16="http://schemas.microsoft.com/office/drawing/2014/main" id="{1AC5979D-7342-4206-0E2F-657D86106D75}"/>
+              </a:ext>
+            </a:extLst>
+          </p:cNvPr>
+          <p:cNvSpPr>
+            <a:spLocks noGrp="1"/>
+          </p:cNvSpPr>
+          <p:nvPr>
+            <p:ph type="title"/>
+          </p:nvPr>
+        </p:nvSpPr>
+        <p:spPr>
+          <a:xfrm>
+            <a:off x="838200" y="365125"/>
+            <a:ext cx="10515600" cy="1325563"/>
+          </a:xfrm>
+        </p:spPr>
+        <p:txBody>
+          <a:bodyPr/>
+          <a:lstStyle/>
+          <a:p>
+            <a:pPr algn="ctr"/>
+            <a:r>
+              <a:rPr lang="en-US" dirty="0"/>
+              <a:t>Modular Agent Architecture </a:t>
+            </a:r>
+          </a:p>
+        </p:txBody>
+      </p:sp>
+      <p:sp>
+        <p:nvSpPr>
+          <p:cNvPr id="7" name="Rectangle: Rounded Corners 6">
+            <a:extLst>
+              <a:ext uri="{FF2B5EF4-FFF2-40B4-BE49-F238E27FC236}">
+                <a16:creationId xmlns:a16="http://schemas.microsoft.com/office/drawing/2014/main" id="{91B4A69E-4A67-5560-25CC-120C76F25095}"/>
               </a:ext>
             </a:extLst>
           </p:cNvPr>
@@ -2998,112 +3032,8 @@
         </p:nvSpPr>
         <p:spPr>
           <a:xfrm>
-            <a:off x="1323467" y="3071061"/>
-            <a:ext cx="1371600" cy="234616"/>
-          </a:xfrm>
-          <a:prstGeom prst="roundRect">
-            <a:avLst/>
-          </a:prstGeom>
-          <a:solidFill>
-            <a:schemeClr val="bg2"/>
-          </a:solidFill>
-          <a:ln>
-            <a:noFill/>
-          </a:ln>
-        </p:spPr>
-        <p:style>
-          <a:lnRef idx="2">
-            <a:schemeClr val="accent1">
-              <a:shade val="15000"/>
-            </a:schemeClr>
-          </a:lnRef>
-          <a:fillRef idx="1">
-            <a:schemeClr val="accent1"/>
-          </a:fillRef>
-          <a:effectRef idx="0">
-            <a:schemeClr val="accent1"/>
-          </a:effectRef>
-          <a:fontRef idx="minor">
-            <a:schemeClr val="lt1"/>
-          </a:fontRef>
-        </p:style>
-        <p:txBody>
-          <a:bodyPr rtlCol="0" anchor="ctr"/>
-          <a:lstStyle/>
-          <a:p>
-            <a:pPr algn="ctr"/>
-            <a:endParaRPr lang="en-US" sz="1600" dirty="0"/>
-          </a:p>
-        </p:txBody>
-      </p:sp>
-      <p:sp>
-        <p:nvSpPr>
-          <p:cNvPr id="64" name="Rectangle: Rounded Corners 63">
-            <a:extLst>
-              <a:ext uri="{FF2B5EF4-FFF2-40B4-BE49-F238E27FC236}">
-                <a16:creationId xmlns:a16="http://schemas.microsoft.com/office/drawing/2014/main" id="{35B34839-78DC-B804-7E7C-A1AE45580E63}"/>
-              </a:ext>
-            </a:extLst>
-          </p:cNvPr>
-          <p:cNvSpPr/>
-          <p:nvPr/>
-        </p:nvSpPr>
-        <p:spPr>
-          <a:xfrm>
-            <a:off x="1311433" y="3522245"/>
-            <a:ext cx="1371600" cy="234616"/>
-          </a:xfrm>
-          <a:prstGeom prst="roundRect">
-            <a:avLst/>
-          </a:prstGeom>
-          <a:solidFill>
-            <a:schemeClr val="bg2"/>
-          </a:solidFill>
-          <a:ln>
-            <a:noFill/>
-          </a:ln>
-        </p:spPr>
-        <p:style>
-          <a:lnRef idx="2">
-            <a:schemeClr val="accent1">
-              <a:shade val="15000"/>
-            </a:schemeClr>
-          </a:lnRef>
-          <a:fillRef idx="1">
-            <a:schemeClr val="accent1"/>
-          </a:fillRef>
-          <a:effectRef idx="0">
-            <a:schemeClr val="accent1"/>
-          </a:effectRef>
-          <a:fontRef idx="minor">
-            <a:schemeClr val="lt1"/>
-          </a:fontRef>
-        </p:style>
-        <p:txBody>
-          <a:bodyPr rtlCol="0" anchor="ctr"/>
-          <a:lstStyle/>
-          <a:p>
-            <a:pPr algn="ctr"/>
-            <a:endParaRPr lang="en-US" sz="1600" dirty="0"/>
-          </a:p>
-        </p:txBody>
-      </p:sp>
-      <p:sp>
-        <p:nvSpPr>
-          <p:cNvPr id="5" name="Rectangle: Rounded Corners 4">
-            <a:extLst>
-              <a:ext uri="{FF2B5EF4-FFF2-40B4-BE49-F238E27FC236}">
-                <a16:creationId xmlns:a16="http://schemas.microsoft.com/office/drawing/2014/main" id="{627A772A-E9A1-90BB-3A79-CD829F0F0104}"/>
-              </a:ext>
-            </a:extLst>
-          </p:cNvPr>
-          <p:cNvSpPr/>
-          <p:nvPr/>
-        </p:nvSpPr>
-        <p:spPr>
-          <a:xfrm>
-            <a:off x="8622627" y="2971800"/>
-            <a:ext cx="1371600" cy="914400"/>
+            <a:off x="5649035" y="3544094"/>
+            <a:ext cx="2286000" cy="914400"/>
           </a:xfrm>
           <a:prstGeom prst="roundRect">
             <a:avLst/>
@@ -3137,18 +3067,18 @@
           <a:p>
             <a:pPr algn="ctr"/>
             <a:r>
-              <a:rPr lang="en-US" sz="1600" dirty="0"/>
-              <a:t>Actor</a:t>
-            </a:r>
-          </a:p>
-        </p:txBody>
-      </p:sp>
-      <p:sp>
-        <p:nvSpPr>
-          <p:cNvPr id="6" name="Rectangle: Rounded Corners 5">
+              <a:rPr lang="en-US" sz="2400" dirty="0"/>
+              <a:t>Reasoner</a:t>
+            </a:r>
+          </a:p>
+        </p:txBody>
+      </p:sp>
+      <p:sp>
+        <p:nvSpPr>
+          <p:cNvPr id="8" name="Rectangle: Rounded Corners 7">
             <a:extLst>
               <a:ext uri="{FF2B5EF4-FFF2-40B4-BE49-F238E27FC236}">
-                <a16:creationId xmlns:a16="http://schemas.microsoft.com/office/drawing/2014/main" id="{2E729B92-9570-0272-FCB1-8ADB356EF025}"/>
+                <a16:creationId xmlns:a16="http://schemas.microsoft.com/office/drawing/2014/main" id="{83909DA7-AE37-E87A-EBA6-1C611540A4F7}"/>
               </a:ext>
             </a:extLst>
           </p:cNvPr>
@@ -3157,116 +3087,8 @@
         </p:nvSpPr>
         <p:spPr>
           <a:xfrm>
-            <a:off x="1331484" y="4331368"/>
-            <a:ext cx="1371600" cy="914400"/>
-          </a:xfrm>
-          <a:prstGeom prst="roundRect">
-            <a:avLst/>
-          </a:prstGeom>
-          <a:solidFill>
-            <a:schemeClr val="accent2"/>
-          </a:solidFill>
-          <a:ln>
-            <a:noFill/>
-          </a:ln>
-        </p:spPr>
-        <p:style>
-          <a:lnRef idx="2">
-            <a:schemeClr val="accent1">
-              <a:shade val="15000"/>
-            </a:schemeClr>
-          </a:lnRef>
-          <a:fillRef idx="1">
-            <a:schemeClr val="accent1"/>
-          </a:fillRef>
-          <a:effectRef idx="0">
-            <a:schemeClr val="accent1"/>
-          </a:effectRef>
-          <a:fontRef idx="minor">
-            <a:schemeClr val="lt1"/>
-          </a:fontRef>
-        </p:style>
-        <p:txBody>
-          <a:bodyPr rtlCol="0" anchor="ctr"/>
-          <a:lstStyle/>
-          <a:p>
-            <a:pPr algn="ctr"/>
-            <a:r>
-              <a:rPr lang="en-US" sz="1600" dirty="0"/>
-              <a:t>Reflector</a:t>
-            </a:r>
-          </a:p>
-        </p:txBody>
-      </p:sp>
-      <p:sp>
-        <p:nvSpPr>
-          <p:cNvPr id="9" name="Rectangle: Rounded Corners 8">
-            <a:extLst>
-              <a:ext uri="{FF2B5EF4-FFF2-40B4-BE49-F238E27FC236}">
-                <a16:creationId xmlns:a16="http://schemas.microsoft.com/office/drawing/2014/main" id="{A21876C7-8090-A865-57ED-932EBE5E13F1}"/>
-              </a:ext>
-            </a:extLst>
-          </p:cNvPr>
-          <p:cNvSpPr/>
-          <p:nvPr/>
-        </p:nvSpPr>
-        <p:spPr>
-          <a:xfrm>
-            <a:off x="3148257" y="4331368"/>
-            <a:ext cx="1371600" cy="914400"/>
-          </a:xfrm>
-          <a:prstGeom prst="roundRect">
-            <a:avLst/>
-          </a:prstGeom>
-          <a:solidFill>
-            <a:schemeClr val="accent3"/>
-          </a:solidFill>
-          <a:ln>
-            <a:noFill/>
-          </a:ln>
-        </p:spPr>
-        <p:style>
-          <a:lnRef idx="0">
-            <a:scrgbClr r="0" g="0" b="0"/>
-          </a:lnRef>
-          <a:fillRef idx="0">
-            <a:scrgbClr r="0" g="0" b="0"/>
-          </a:fillRef>
-          <a:effectRef idx="0">
-            <a:scrgbClr r="0" g="0" b="0"/>
-          </a:effectRef>
-          <a:fontRef idx="minor">
-            <a:schemeClr val="lt1"/>
-          </a:fontRef>
-        </p:style>
-        <p:txBody>
-          <a:bodyPr rtlCol="0" anchor="ctr"/>
-          <a:lstStyle/>
-          <a:p>
-            <a:pPr algn="ctr"/>
-            <a:r>
-              <a:rPr lang="en-US" sz="1600" dirty="0"/>
-              <a:t>Reviewer</a:t>
-            </a:r>
-          </a:p>
-        </p:txBody>
-      </p:sp>
-      <p:sp>
-        <p:nvSpPr>
-          <p:cNvPr id="11" name="Rectangle: Rounded Corners 10">
-            <a:extLst>
-              <a:ext uri="{FF2B5EF4-FFF2-40B4-BE49-F238E27FC236}">
-                <a16:creationId xmlns:a16="http://schemas.microsoft.com/office/drawing/2014/main" id="{62B23C4A-F749-8DD7-7AEE-C04A3C7969D5}"/>
-              </a:ext>
-            </a:extLst>
-          </p:cNvPr>
-          <p:cNvSpPr/>
-          <p:nvPr/>
-        </p:nvSpPr>
-        <p:spPr>
-          <a:xfrm>
-            <a:off x="1323467" y="2971800"/>
-            <a:ext cx="1371600" cy="914400"/>
+            <a:off x="2448635" y="3544094"/>
+            <a:ext cx="2286000" cy="914400"/>
           </a:xfrm>
           <a:prstGeom prst="roundRect">
             <a:avLst/>
@@ -3300,18 +3122,18 @@
           <a:p>
             <a:pPr algn="ctr"/>
             <a:r>
-              <a:rPr lang="en-US" sz="1600" dirty="0"/>
-              <a:t>Planner</a:t>
-            </a:r>
-          </a:p>
-        </p:txBody>
-      </p:sp>
-      <p:sp>
-        <p:nvSpPr>
-          <p:cNvPr id="12" name="Rectangle: Rounded Corners 11">
+              <a:rPr lang="en-US" sz="2400" dirty="0"/>
+              <a:t>Summarizer</a:t>
+            </a:r>
+          </a:p>
+        </p:txBody>
+      </p:sp>
+      <p:sp>
+        <p:nvSpPr>
+          <p:cNvPr id="10" name="Rectangle: Rounded Corners 9">
             <a:extLst>
               <a:ext uri="{FF2B5EF4-FFF2-40B4-BE49-F238E27FC236}">
-                <a16:creationId xmlns:a16="http://schemas.microsoft.com/office/drawing/2014/main" id="{0336AEB3-C061-F2D7-F4A3-15502D822309}"/>
+                <a16:creationId xmlns:a16="http://schemas.microsoft.com/office/drawing/2014/main" id="{35A10CFF-258B-E319-C50C-B45C912A0FB5}"/>
               </a:ext>
             </a:extLst>
           </p:cNvPr>
@@ -3320,8 +3142,8 @@
         </p:nvSpPr>
         <p:spPr>
           <a:xfrm>
-            <a:off x="3148257" y="2971800"/>
-            <a:ext cx="1371600" cy="914400"/>
+            <a:off x="2448635" y="2216512"/>
+            <a:ext cx="2286000" cy="914400"/>
           </a:xfrm>
           <a:prstGeom prst="roundRect">
             <a:avLst/>
@@ -3355,18 +3177,18 @@
           <a:p>
             <a:pPr algn="ctr"/>
             <a:r>
-              <a:rPr lang="en-US" sz="1600" dirty="0"/>
-              <a:t>Summarizer</a:t>
-            </a:r>
-          </a:p>
-        </p:txBody>
-      </p:sp>
-      <p:sp>
-        <p:nvSpPr>
-          <p:cNvPr id="13" name="Rectangle: Rounded Corners 12">
+              <a:rPr lang="en-US" sz="2400" dirty="0"/>
+              <a:t>Planner</a:t>
+            </a:r>
+          </a:p>
+        </p:txBody>
+      </p:sp>
+      <p:sp>
+        <p:nvSpPr>
+          <p:cNvPr id="16" name="Rectangle: Rounded Corners 15">
             <a:extLst>
               <a:ext uri="{FF2B5EF4-FFF2-40B4-BE49-F238E27FC236}">
-                <a16:creationId xmlns:a16="http://schemas.microsoft.com/office/drawing/2014/main" id="{78EF932F-00C5-F3A3-603A-46BD117CBFE9}"/>
+                <a16:creationId xmlns:a16="http://schemas.microsoft.com/office/drawing/2014/main" id="{7BCEAC8F-4A37-521E-878B-DAEC09BDBECD}"/>
               </a:ext>
             </a:extLst>
           </p:cNvPr>
@@ -3375,8 +3197,8 @@
         </p:nvSpPr>
         <p:spPr>
           <a:xfrm>
-            <a:off x="4985081" y="2971800"/>
-            <a:ext cx="1371600" cy="914400"/>
+            <a:off x="2448635" y="4871676"/>
+            <a:ext cx="2286000" cy="914400"/>
           </a:xfrm>
           <a:prstGeom prst="roundRect">
             <a:avLst/>
@@ -3410,7 +3232,7 @@
           <a:p>
             <a:pPr algn="ctr"/>
             <a:r>
-              <a:rPr lang="en-US" sz="1600" dirty="0"/>
+              <a:rPr lang="en-US" sz="2400" dirty="0"/>
               <a:t>Memorizer</a:t>
             </a:r>
           </a:p>
@@ -3418,10 +3240,10 @@
       </p:sp>
       <p:sp>
         <p:nvSpPr>
-          <p:cNvPr id="14" name="Rectangle: Rounded Corners 13">
+          <p:cNvPr id="17" name="Rectangle: Rounded Corners 16">
             <a:extLst>
               <a:ext uri="{FF2B5EF4-FFF2-40B4-BE49-F238E27FC236}">
-                <a16:creationId xmlns:a16="http://schemas.microsoft.com/office/drawing/2014/main" id="{BAF55CC2-93AA-7AF3-6158-71C741B0CA87}"/>
+                <a16:creationId xmlns:a16="http://schemas.microsoft.com/office/drawing/2014/main" id="{A0F036B2-DB93-0095-39E4-35073A9E6BD8}"/>
               </a:ext>
             </a:extLst>
           </p:cNvPr>
@@ -3430,8 +3252,8 @@
         </p:nvSpPr>
         <p:spPr>
           <a:xfrm>
-            <a:off x="6797837" y="2971800"/>
-            <a:ext cx="1371600" cy="914400"/>
+            <a:off x="8849435" y="3544094"/>
+            <a:ext cx="2286000" cy="914400"/>
           </a:xfrm>
           <a:prstGeom prst="roundRect">
             <a:avLst/>
@@ -3465,18 +3287,250 @@
           <a:p>
             <a:pPr algn="ctr"/>
             <a:r>
-              <a:rPr lang="en-US" sz="1600" dirty="0"/>
-              <a:t>Reasoner</a:t>
-            </a:r>
-          </a:p>
-        </p:txBody>
-      </p:sp>
-      <p:sp>
-        <p:nvSpPr>
-          <p:cNvPr id="15" name="Rectangle: Rounded Corners 14">
+              <a:rPr lang="en-US" sz="2400" dirty="0"/>
+              <a:t>Actor</a:t>
+            </a:r>
+          </a:p>
+        </p:txBody>
+      </p:sp>
+      <p:cxnSp>
+        <p:nvCxnSpPr>
+          <p:cNvPr id="21" name="Connector: Elbow 20">
             <a:extLst>
               <a:ext uri="{FF2B5EF4-FFF2-40B4-BE49-F238E27FC236}">
-                <a16:creationId xmlns:a16="http://schemas.microsoft.com/office/drawing/2014/main" id="{A67D181F-D06D-BB84-452D-BCFEC1FCA710}"/>
+                <a16:creationId xmlns:a16="http://schemas.microsoft.com/office/drawing/2014/main" id="{5EB942D7-B7D1-69C3-E302-56E21AFA7823}"/>
+              </a:ext>
+            </a:extLst>
+          </p:cNvPr>
+          <p:cNvCxnSpPr>
+            <a:stCxn id="10" idx="3"/>
+            <a:endCxn id="7" idx="1"/>
+          </p:cNvCxnSpPr>
+          <p:nvPr/>
+        </p:nvCxnSpPr>
+        <p:spPr>
+          <a:xfrm>
+            <a:off x="4734635" y="2673712"/>
+            <a:ext cx="914400" cy="1327582"/>
+          </a:xfrm>
+          <a:prstGeom prst="bentConnector3">
+            <a:avLst/>
+          </a:prstGeom>
+          <a:ln w="38100">
+            <a:solidFill>
+              <a:schemeClr val="accent3"/>
+            </a:solidFill>
+            <a:tailEnd type="triangle"/>
+          </a:ln>
+        </p:spPr>
+        <p:style>
+          <a:lnRef idx="1">
+            <a:schemeClr val="accent1"/>
+          </a:lnRef>
+          <a:fillRef idx="0">
+            <a:schemeClr val="accent1"/>
+          </a:fillRef>
+          <a:effectRef idx="0">
+            <a:schemeClr val="accent1"/>
+          </a:effectRef>
+          <a:fontRef idx="minor">
+            <a:schemeClr val="tx1"/>
+          </a:fontRef>
+        </p:style>
+      </p:cxnSp>
+      <p:cxnSp>
+        <p:nvCxnSpPr>
+          <p:cNvPr id="22" name="Connector: Elbow 21">
+            <a:extLst>
+              <a:ext uri="{FF2B5EF4-FFF2-40B4-BE49-F238E27FC236}">
+                <a16:creationId xmlns:a16="http://schemas.microsoft.com/office/drawing/2014/main" id="{7D2708D9-881A-F4BD-4478-552B767870DD}"/>
+              </a:ext>
+            </a:extLst>
+          </p:cNvPr>
+          <p:cNvCxnSpPr>
+            <a:cxnSpLocks/>
+            <a:stCxn id="16" idx="3"/>
+            <a:endCxn id="7" idx="1"/>
+          </p:cNvCxnSpPr>
+          <p:nvPr/>
+        </p:nvCxnSpPr>
+        <p:spPr>
+          <a:xfrm flipV="1">
+            <a:off x="4734635" y="4001294"/>
+            <a:ext cx="914400" cy="1327582"/>
+          </a:xfrm>
+          <a:prstGeom prst="bentConnector3">
+            <a:avLst>
+              <a:gd name="adj1" fmla="val 50000"/>
+            </a:avLst>
+          </a:prstGeom>
+          <a:ln w="38100">
+            <a:solidFill>
+              <a:schemeClr val="accent3"/>
+            </a:solidFill>
+            <a:tailEnd type="triangle"/>
+          </a:ln>
+        </p:spPr>
+        <p:style>
+          <a:lnRef idx="1">
+            <a:schemeClr val="accent1"/>
+          </a:lnRef>
+          <a:fillRef idx="0">
+            <a:schemeClr val="accent1"/>
+          </a:fillRef>
+          <a:effectRef idx="0">
+            <a:schemeClr val="accent1"/>
+          </a:effectRef>
+          <a:fontRef idx="minor">
+            <a:schemeClr val="tx1"/>
+          </a:fontRef>
+        </p:style>
+      </p:cxnSp>
+      <p:cxnSp>
+        <p:nvCxnSpPr>
+          <p:cNvPr id="23" name="Straight Arrow Connector 22">
+            <a:extLst>
+              <a:ext uri="{FF2B5EF4-FFF2-40B4-BE49-F238E27FC236}">
+                <a16:creationId xmlns:a16="http://schemas.microsoft.com/office/drawing/2014/main" id="{57FD3A21-46E4-90B3-9C11-1374157CC142}"/>
+              </a:ext>
+            </a:extLst>
+          </p:cNvPr>
+          <p:cNvCxnSpPr>
+            <a:endCxn id="7" idx="1"/>
+          </p:cNvCxnSpPr>
+          <p:nvPr/>
+        </p:nvCxnSpPr>
+        <p:spPr>
+          <a:xfrm>
+            <a:off x="4734635" y="4001294"/>
+            <a:ext cx="914400" cy="0"/>
+          </a:xfrm>
+          <a:prstGeom prst="straightConnector1">
+            <a:avLst/>
+          </a:prstGeom>
+          <a:ln w="38100">
+            <a:solidFill>
+              <a:schemeClr val="accent3"/>
+            </a:solidFill>
+            <a:tailEnd type="triangle"/>
+          </a:ln>
+        </p:spPr>
+        <p:style>
+          <a:lnRef idx="1">
+            <a:schemeClr val="accent1"/>
+          </a:lnRef>
+          <a:fillRef idx="0">
+            <a:schemeClr val="accent1"/>
+          </a:fillRef>
+          <a:effectRef idx="0">
+            <a:schemeClr val="accent1"/>
+          </a:effectRef>
+          <a:fontRef idx="minor">
+            <a:schemeClr val="tx1"/>
+          </a:fontRef>
+        </p:style>
+      </p:cxnSp>
+      <p:cxnSp>
+        <p:nvCxnSpPr>
+          <p:cNvPr id="24" name="Straight Arrow Connector 23">
+            <a:extLst>
+              <a:ext uri="{FF2B5EF4-FFF2-40B4-BE49-F238E27FC236}">
+                <a16:creationId xmlns:a16="http://schemas.microsoft.com/office/drawing/2014/main" id="{0F4B248C-BC58-B17D-2223-4D17727812ED}"/>
+              </a:ext>
+            </a:extLst>
+          </p:cNvPr>
+          <p:cNvCxnSpPr>
+            <a:cxnSpLocks/>
+            <a:stCxn id="7" idx="3"/>
+            <a:endCxn id="17" idx="1"/>
+          </p:cNvCxnSpPr>
+          <p:nvPr/>
+        </p:nvCxnSpPr>
+        <p:spPr>
+          <a:xfrm>
+            <a:off x="7935035" y="4001294"/>
+            <a:ext cx="914400" cy="0"/>
+          </a:xfrm>
+          <a:prstGeom prst="straightConnector1">
+            <a:avLst/>
+          </a:prstGeom>
+          <a:ln w="38100">
+            <a:solidFill>
+              <a:schemeClr val="accent3"/>
+            </a:solidFill>
+            <a:tailEnd type="triangle"/>
+          </a:ln>
+        </p:spPr>
+        <p:style>
+          <a:lnRef idx="1">
+            <a:schemeClr val="accent1"/>
+          </a:lnRef>
+          <a:fillRef idx="0">
+            <a:schemeClr val="accent1"/>
+          </a:fillRef>
+          <a:effectRef idx="0">
+            <a:schemeClr val="accent1"/>
+          </a:effectRef>
+          <a:fontRef idx="minor">
+            <a:schemeClr val="tx1"/>
+          </a:fontRef>
+        </p:style>
+      </p:cxnSp>
+      <p:cxnSp>
+        <p:nvCxnSpPr>
+          <p:cNvPr id="25" name="Connector: Elbow 24">
+            <a:extLst>
+              <a:ext uri="{FF2B5EF4-FFF2-40B4-BE49-F238E27FC236}">
+                <a16:creationId xmlns:a16="http://schemas.microsoft.com/office/drawing/2014/main" id="{31EE59FA-66D8-4A88-BB1D-DB4FD4613B76}"/>
+              </a:ext>
+            </a:extLst>
+          </p:cNvPr>
+          <p:cNvCxnSpPr>
+            <a:cxnSpLocks/>
+            <a:stCxn id="17" idx="3"/>
+          </p:cNvCxnSpPr>
+          <p:nvPr/>
+        </p:nvCxnSpPr>
+        <p:spPr>
+          <a:xfrm flipH="1">
+            <a:off x="838200" y="4001294"/>
+            <a:ext cx="10297235" cy="12700"/>
+          </a:xfrm>
+          <a:prstGeom prst="bentConnector5">
+            <a:avLst>
+              <a:gd name="adj1" fmla="val -2220"/>
+              <a:gd name="adj2" fmla="val 18931252"/>
+              <a:gd name="adj3" fmla="val 102220"/>
+            </a:avLst>
+          </a:prstGeom>
+          <a:ln w="38100">
+            <a:solidFill>
+              <a:schemeClr val="accent3"/>
+            </a:solidFill>
+            <a:tailEnd type="triangle"/>
+          </a:ln>
+        </p:spPr>
+        <p:style>
+          <a:lnRef idx="1">
+            <a:schemeClr val="accent1"/>
+          </a:lnRef>
+          <a:fillRef idx="0">
+            <a:schemeClr val="accent1"/>
+          </a:fillRef>
+          <a:effectRef idx="0">
+            <a:schemeClr val="accent1"/>
+          </a:effectRef>
+          <a:fontRef idx="minor">
+            <a:schemeClr val="tx1"/>
+          </a:fontRef>
+        </p:style>
+      </p:cxnSp>
+      <p:sp>
+        <p:nvSpPr>
+          <p:cNvPr id="26" name="Oval 25">
+            <a:extLst>
+              <a:ext uri="{FF2B5EF4-FFF2-40B4-BE49-F238E27FC236}">
+                <a16:creationId xmlns:a16="http://schemas.microsoft.com/office/drawing/2014/main" id="{CF93FAA6-6051-131F-3CCC-8D64F06A7D14}"/>
               </a:ext>
             </a:extLst>
           </p:cNvPr>
@@ -3485,14 +3539,14 @@
         </p:nvSpPr>
         <p:spPr>
           <a:xfrm>
-            <a:off x="10447417" y="2959769"/>
-            <a:ext cx="1371600" cy="914400"/>
+            <a:off x="838200" y="3544094"/>
+            <a:ext cx="914400" cy="914400"/>
           </a:xfrm>
-          <a:prstGeom prst="roundRect">
+          <a:prstGeom prst="ellipse">
             <a:avLst/>
           </a:prstGeom>
           <a:solidFill>
-            <a:schemeClr val="accent2"/>
+            <a:schemeClr val="accent5"/>
           </a:solidFill>
           <a:ln>
             <a:noFill/>
@@ -3515,23 +3569,208 @@
           </a:fontRef>
         </p:style>
         <p:txBody>
-          <a:bodyPr rtlCol="0" anchor="ctr"/>
+          <a:bodyPr lIns="0" tIns="0" rIns="0" bIns="0" rtlCol="0" anchor="ctr"/>
           <a:lstStyle/>
           <a:p>
             <a:pPr algn="ctr"/>
             <a:r>
-              <a:rPr lang="en-US" sz="1600" dirty="0"/>
-              <a:t>Predictor</a:t>
-            </a:r>
-          </a:p>
-        </p:txBody>
-      </p:sp>
-      <p:sp>
-        <p:nvSpPr>
-          <p:cNvPr id="18" name="Rectangle 17">
+              <a:rPr lang="en-US" dirty="0"/>
+              <a:t>State</a:t>
+            </a:r>
+          </a:p>
+        </p:txBody>
+      </p:sp>
+      <p:cxnSp>
+        <p:nvCxnSpPr>
+          <p:cNvPr id="28" name="Connector: Elbow 27">
             <a:extLst>
               <a:ext uri="{FF2B5EF4-FFF2-40B4-BE49-F238E27FC236}">
-                <a16:creationId xmlns:a16="http://schemas.microsoft.com/office/drawing/2014/main" id="{A2ED21B0-B111-64CC-2950-84704E4D28C0}"/>
+                <a16:creationId xmlns:a16="http://schemas.microsoft.com/office/drawing/2014/main" id="{AFCF92F4-04D3-6F55-B1BD-FA8893AF01BE}"/>
+              </a:ext>
+            </a:extLst>
+          </p:cNvPr>
+          <p:cNvCxnSpPr>
+            <a:cxnSpLocks/>
+            <a:stCxn id="26" idx="6"/>
+            <a:endCxn id="10" idx="1"/>
+          </p:cNvCxnSpPr>
+          <p:nvPr/>
+        </p:nvCxnSpPr>
+        <p:spPr>
+          <a:xfrm flipV="1">
+            <a:off x="1752600" y="2673712"/>
+            <a:ext cx="696035" cy="1327582"/>
+          </a:xfrm>
+          <a:prstGeom prst="bentConnector3">
+            <a:avLst/>
+          </a:prstGeom>
+          <a:ln w="38100">
+            <a:solidFill>
+              <a:schemeClr val="accent3"/>
+            </a:solidFill>
+            <a:tailEnd type="triangle"/>
+          </a:ln>
+        </p:spPr>
+        <p:style>
+          <a:lnRef idx="1">
+            <a:schemeClr val="accent1"/>
+          </a:lnRef>
+          <a:fillRef idx="0">
+            <a:schemeClr val="accent1"/>
+          </a:fillRef>
+          <a:effectRef idx="0">
+            <a:schemeClr val="accent1"/>
+          </a:effectRef>
+          <a:fontRef idx="minor">
+            <a:schemeClr val="tx1"/>
+          </a:fontRef>
+        </p:style>
+      </p:cxnSp>
+      <p:cxnSp>
+        <p:nvCxnSpPr>
+          <p:cNvPr id="35" name="Connector: Elbow 34">
+            <a:extLst>
+              <a:ext uri="{FF2B5EF4-FFF2-40B4-BE49-F238E27FC236}">
+                <a16:creationId xmlns:a16="http://schemas.microsoft.com/office/drawing/2014/main" id="{3E77A9C4-8F86-6169-8E5D-28DC23A586B6}"/>
+              </a:ext>
+            </a:extLst>
+          </p:cNvPr>
+          <p:cNvCxnSpPr>
+            <a:cxnSpLocks/>
+            <a:stCxn id="26" idx="6"/>
+            <a:endCxn id="16" idx="1"/>
+          </p:cNvCxnSpPr>
+          <p:nvPr/>
+        </p:nvCxnSpPr>
+        <p:spPr>
+          <a:xfrm>
+            <a:off x="1752600" y="4001294"/>
+            <a:ext cx="696035" cy="1327582"/>
+          </a:xfrm>
+          <a:prstGeom prst="bentConnector3">
+            <a:avLst>
+              <a:gd name="adj1" fmla="val 50000"/>
+            </a:avLst>
+          </a:prstGeom>
+          <a:ln w="38100">
+            <a:solidFill>
+              <a:schemeClr val="accent3"/>
+            </a:solidFill>
+            <a:tailEnd type="triangle"/>
+          </a:ln>
+        </p:spPr>
+        <p:style>
+          <a:lnRef idx="1">
+            <a:schemeClr val="accent1"/>
+          </a:lnRef>
+          <a:fillRef idx="0">
+            <a:schemeClr val="accent1"/>
+          </a:fillRef>
+          <a:effectRef idx="0">
+            <a:schemeClr val="accent1"/>
+          </a:effectRef>
+          <a:fontRef idx="minor">
+            <a:schemeClr val="tx1"/>
+          </a:fontRef>
+        </p:style>
+      </p:cxnSp>
+      <p:cxnSp>
+        <p:nvCxnSpPr>
+          <p:cNvPr id="36" name="Straight Arrow Connector 35">
+            <a:extLst>
+              <a:ext uri="{FF2B5EF4-FFF2-40B4-BE49-F238E27FC236}">
+                <a16:creationId xmlns:a16="http://schemas.microsoft.com/office/drawing/2014/main" id="{643B2C1D-5BD6-4CDF-64ED-8A1615E73681}"/>
+              </a:ext>
+            </a:extLst>
+          </p:cNvPr>
+          <p:cNvCxnSpPr>
+            <a:cxnSpLocks/>
+            <a:endCxn id="8" idx="1"/>
+          </p:cNvCxnSpPr>
+          <p:nvPr/>
+        </p:nvCxnSpPr>
+        <p:spPr>
+          <a:xfrm flipV="1">
+            <a:off x="1752600" y="4001294"/>
+            <a:ext cx="696035" cy="17475"/>
+          </a:xfrm>
+          <a:prstGeom prst="straightConnector1">
+            <a:avLst/>
+          </a:prstGeom>
+          <a:ln w="38100">
+            <a:solidFill>
+              <a:schemeClr val="accent3"/>
+            </a:solidFill>
+            <a:tailEnd type="triangle"/>
+          </a:ln>
+        </p:spPr>
+        <p:style>
+          <a:lnRef idx="1">
+            <a:schemeClr val="accent1"/>
+          </a:lnRef>
+          <a:fillRef idx="0">
+            <a:schemeClr val="accent1"/>
+          </a:fillRef>
+          <a:effectRef idx="0">
+            <a:schemeClr val="accent1"/>
+          </a:effectRef>
+          <a:fontRef idx="minor">
+            <a:schemeClr val="tx1"/>
+          </a:fontRef>
+        </p:style>
+      </p:cxnSp>
+      <p:cxnSp>
+        <p:nvCxnSpPr>
+          <p:cNvPr id="37" name="Straight Arrow Connector 36">
+            <a:extLst>
+              <a:ext uri="{FF2B5EF4-FFF2-40B4-BE49-F238E27FC236}">
+                <a16:creationId xmlns:a16="http://schemas.microsoft.com/office/drawing/2014/main" id="{1A84D930-4201-6047-00C6-BD40A18EF8AE}"/>
+              </a:ext>
+            </a:extLst>
+          </p:cNvPr>
+          <p:cNvCxnSpPr>
+            <a:cxnSpLocks/>
+            <a:stCxn id="38" idx="4"/>
+            <a:endCxn id="26" idx="0"/>
+          </p:cNvCxnSpPr>
+          <p:nvPr/>
+        </p:nvCxnSpPr>
+        <p:spPr>
+          <a:xfrm>
+            <a:off x="1295400" y="2695721"/>
+            <a:ext cx="0" cy="848373"/>
+          </a:xfrm>
+          <a:prstGeom prst="straightConnector1">
+            <a:avLst/>
+          </a:prstGeom>
+          <a:ln w="38100">
+            <a:solidFill>
+              <a:schemeClr val="accent3"/>
+            </a:solidFill>
+            <a:tailEnd type="triangle"/>
+          </a:ln>
+        </p:spPr>
+        <p:style>
+          <a:lnRef idx="1">
+            <a:schemeClr val="accent1"/>
+          </a:lnRef>
+          <a:fillRef idx="0">
+            <a:schemeClr val="accent1"/>
+          </a:fillRef>
+          <a:effectRef idx="0">
+            <a:schemeClr val="accent1"/>
+          </a:effectRef>
+          <a:fontRef idx="minor">
+            <a:schemeClr val="tx1"/>
+          </a:fontRef>
+        </p:style>
+      </p:cxnSp>
+      <p:sp>
+        <p:nvSpPr>
+          <p:cNvPr id="38" name="Oval 37">
+            <a:extLst>
+              <a:ext uri="{FF2B5EF4-FFF2-40B4-BE49-F238E27FC236}">
+                <a16:creationId xmlns:a16="http://schemas.microsoft.com/office/drawing/2014/main" id="{94157821-5FFF-29EA-2A56-732195516BFA}"/>
               </a:ext>
             </a:extLst>
           </p:cNvPr>
@@ -3540,13 +3779,15 @@
         </p:nvSpPr>
         <p:spPr>
           <a:xfrm>
-            <a:off x="156406" y="1858879"/>
-            <a:ext cx="952500" cy="421106"/>
+            <a:off x="838200" y="1781321"/>
+            <a:ext cx="914400" cy="914400"/>
           </a:xfrm>
-          <a:prstGeom prst="rect">
+          <a:prstGeom prst="ellipse">
             <a:avLst/>
           </a:prstGeom>
-          <a:noFill/>
+          <a:solidFill>
+            <a:schemeClr val="accent5"/>
+          </a:solidFill>
           <a:ln>
             <a:noFill/>
           </a:ln>
@@ -3571,553 +3812,10 @@
           <a:bodyPr rtlCol="0" anchor="ctr"/>
           <a:lstStyle/>
           <a:p>
-            <a:pPr algn="r"/>
-            <a:r>
-              <a:rPr lang="en-US" sz="1600" dirty="0">
-                <a:solidFill>
-                  <a:sysClr val="windowText" lastClr="000000"/>
-                </a:solidFill>
-              </a:rPr>
-              <a:t>Step 1:</a:t>
-            </a:r>
-          </a:p>
-        </p:txBody>
-      </p:sp>
-      <p:sp>
-        <p:nvSpPr>
-          <p:cNvPr id="19" name="Rectangle 18">
-            <a:extLst>
-              <a:ext uri="{FF2B5EF4-FFF2-40B4-BE49-F238E27FC236}">
-                <a16:creationId xmlns:a16="http://schemas.microsoft.com/office/drawing/2014/main" id="{857C46D1-8847-6DF4-5FA5-3D5EC8EFDD76}"/>
-              </a:ext>
-            </a:extLst>
-          </p:cNvPr>
-          <p:cNvSpPr/>
-          <p:nvPr/>
-        </p:nvSpPr>
-        <p:spPr>
-          <a:xfrm>
-            <a:off x="156406" y="3218447"/>
-            <a:ext cx="952500" cy="421106"/>
-          </a:xfrm>
-          <a:prstGeom prst="rect">
-            <a:avLst/>
-          </a:prstGeom>
-          <a:noFill/>
-          <a:ln>
-            <a:noFill/>
-          </a:ln>
-        </p:spPr>
-        <p:style>
-          <a:lnRef idx="2">
-            <a:schemeClr val="accent1">
-              <a:shade val="15000"/>
-            </a:schemeClr>
-          </a:lnRef>
-          <a:fillRef idx="1">
-            <a:schemeClr val="accent1"/>
-          </a:fillRef>
-          <a:effectRef idx="0">
-            <a:schemeClr val="accent1"/>
-          </a:effectRef>
-          <a:fontRef idx="minor">
-            <a:schemeClr val="lt1"/>
-          </a:fontRef>
-        </p:style>
-        <p:txBody>
-          <a:bodyPr rtlCol="0" anchor="ctr"/>
-          <a:lstStyle/>
-          <a:p>
-            <a:pPr algn="r"/>
-            <a:r>
-              <a:rPr lang="en-US" sz="1600" dirty="0">
-                <a:solidFill>
-                  <a:sysClr val="windowText" lastClr="000000"/>
-                </a:solidFill>
-              </a:rPr>
-              <a:t>Step 1-n:</a:t>
-            </a:r>
-          </a:p>
-        </p:txBody>
-      </p:sp>
-      <p:sp>
-        <p:nvSpPr>
-          <p:cNvPr id="20" name="Rectangle 19">
-            <a:extLst>
-              <a:ext uri="{FF2B5EF4-FFF2-40B4-BE49-F238E27FC236}">
-                <a16:creationId xmlns:a16="http://schemas.microsoft.com/office/drawing/2014/main" id="{75F89A13-165A-97FA-96B4-AB550897A480}"/>
-              </a:ext>
-            </a:extLst>
-          </p:cNvPr>
-          <p:cNvSpPr/>
-          <p:nvPr/>
-        </p:nvSpPr>
-        <p:spPr>
-          <a:xfrm>
-            <a:off x="156406" y="4578015"/>
-            <a:ext cx="952500" cy="421106"/>
-          </a:xfrm>
-          <a:prstGeom prst="rect">
-            <a:avLst/>
-          </a:prstGeom>
-          <a:noFill/>
-          <a:ln>
-            <a:noFill/>
-          </a:ln>
-        </p:spPr>
-        <p:style>
-          <a:lnRef idx="2">
-            <a:schemeClr val="accent1">
-              <a:shade val="15000"/>
-            </a:schemeClr>
-          </a:lnRef>
-          <a:fillRef idx="1">
-            <a:schemeClr val="accent1"/>
-          </a:fillRef>
-          <a:effectRef idx="0">
-            <a:schemeClr val="accent1"/>
-          </a:effectRef>
-          <a:fontRef idx="minor">
-            <a:schemeClr val="lt1"/>
-          </a:fontRef>
-        </p:style>
-        <p:txBody>
-          <a:bodyPr rtlCol="0" anchor="ctr"/>
-          <a:lstStyle/>
-          <a:p>
-            <a:pPr algn="r"/>
-            <a:r>
-              <a:rPr lang="en-US" sz="1600" dirty="0">
-                <a:solidFill>
-                  <a:sysClr val="windowText" lastClr="000000"/>
-                </a:solidFill>
-              </a:rPr>
-              <a:t>Step n:</a:t>
-            </a:r>
-          </a:p>
-        </p:txBody>
-      </p:sp>
-      <p:cxnSp>
-        <p:nvCxnSpPr>
-          <p:cNvPr id="27" name="Connector: Elbow 26">
-            <a:extLst>
-              <a:ext uri="{FF2B5EF4-FFF2-40B4-BE49-F238E27FC236}">
-                <a16:creationId xmlns:a16="http://schemas.microsoft.com/office/drawing/2014/main" id="{70CB9252-FB6A-3501-6D6E-89102CA493D9}"/>
-              </a:ext>
-            </a:extLst>
-          </p:cNvPr>
-          <p:cNvCxnSpPr>
-            <a:cxnSpLocks/>
-            <a:stCxn id="18" idx="3"/>
-            <a:endCxn id="62" idx="1"/>
-          </p:cNvCxnSpPr>
-          <p:nvPr/>
-        </p:nvCxnSpPr>
-        <p:spPr>
-          <a:xfrm>
-            <a:off x="1108906" y="2069432"/>
-            <a:ext cx="214561" cy="1118937"/>
-          </a:xfrm>
-          <a:prstGeom prst="bentConnector3">
-            <a:avLst>
-              <a:gd name="adj1" fmla="val 50000"/>
-            </a:avLst>
-          </a:prstGeom>
-          <a:ln>
-            <a:tailEnd type="triangle"/>
-          </a:ln>
-        </p:spPr>
-        <p:style>
-          <a:lnRef idx="1">
-            <a:schemeClr val="accent1"/>
-          </a:lnRef>
-          <a:fillRef idx="0">
-            <a:schemeClr val="accent1"/>
-          </a:fillRef>
-          <a:effectRef idx="0">
-            <a:schemeClr val="accent1"/>
-          </a:effectRef>
-          <a:fontRef idx="minor">
-            <a:schemeClr val="tx1"/>
-          </a:fontRef>
-        </p:style>
-      </p:cxnSp>
-      <p:cxnSp>
-        <p:nvCxnSpPr>
-          <p:cNvPr id="29" name="Straight Arrow Connector 28">
-            <a:extLst>
-              <a:ext uri="{FF2B5EF4-FFF2-40B4-BE49-F238E27FC236}">
-                <a16:creationId xmlns:a16="http://schemas.microsoft.com/office/drawing/2014/main" id="{35F26AE1-586B-4CDC-3C4E-6B60A537727A}"/>
-              </a:ext>
-            </a:extLst>
-          </p:cNvPr>
-          <p:cNvCxnSpPr>
-            <a:stCxn id="11" idx="3"/>
-            <a:endCxn id="12" idx="1"/>
-          </p:cNvCxnSpPr>
-          <p:nvPr/>
-        </p:nvCxnSpPr>
-        <p:spPr>
-          <a:xfrm>
-            <a:off x="2695067" y="3429000"/>
-            <a:ext cx="453190" cy="0"/>
-          </a:xfrm>
-          <a:prstGeom prst="straightConnector1">
-            <a:avLst/>
-          </a:prstGeom>
-          <a:ln>
-            <a:tailEnd type="triangle"/>
-          </a:ln>
-        </p:spPr>
-        <p:style>
-          <a:lnRef idx="1">
-            <a:schemeClr val="accent1"/>
-          </a:lnRef>
-          <a:fillRef idx="0">
-            <a:schemeClr val="accent1"/>
-          </a:fillRef>
-          <a:effectRef idx="0">
-            <a:schemeClr val="accent1"/>
-          </a:effectRef>
-          <a:fontRef idx="minor">
-            <a:schemeClr val="tx1"/>
-          </a:fontRef>
-        </p:style>
-      </p:cxnSp>
-      <p:cxnSp>
-        <p:nvCxnSpPr>
-          <p:cNvPr id="30" name="Straight Arrow Connector 29">
-            <a:extLst>
-              <a:ext uri="{FF2B5EF4-FFF2-40B4-BE49-F238E27FC236}">
-                <a16:creationId xmlns:a16="http://schemas.microsoft.com/office/drawing/2014/main" id="{6AC97757-F17C-2FB5-A704-98C93269542B}"/>
-              </a:ext>
-            </a:extLst>
-          </p:cNvPr>
-          <p:cNvCxnSpPr>
-            <a:cxnSpLocks/>
-            <a:stCxn id="12" idx="3"/>
-            <a:endCxn id="13" idx="1"/>
-          </p:cNvCxnSpPr>
-          <p:nvPr/>
-        </p:nvCxnSpPr>
-        <p:spPr>
-          <a:xfrm>
-            <a:off x="4519857" y="3429000"/>
-            <a:ext cx="465224" cy="0"/>
-          </a:xfrm>
-          <a:prstGeom prst="straightConnector1">
-            <a:avLst/>
-          </a:prstGeom>
-          <a:ln>
-            <a:tailEnd type="triangle"/>
-          </a:ln>
-        </p:spPr>
-        <p:style>
-          <a:lnRef idx="1">
-            <a:schemeClr val="accent1"/>
-          </a:lnRef>
-          <a:fillRef idx="0">
-            <a:schemeClr val="accent1"/>
-          </a:fillRef>
-          <a:effectRef idx="0">
-            <a:schemeClr val="accent1"/>
-          </a:effectRef>
-          <a:fontRef idx="minor">
-            <a:schemeClr val="tx1"/>
-          </a:fontRef>
-        </p:style>
-      </p:cxnSp>
-      <p:cxnSp>
-        <p:nvCxnSpPr>
-          <p:cNvPr id="31" name="Straight Arrow Connector 30">
-            <a:extLst>
-              <a:ext uri="{FF2B5EF4-FFF2-40B4-BE49-F238E27FC236}">
-                <a16:creationId xmlns:a16="http://schemas.microsoft.com/office/drawing/2014/main" id="{9412370A-AD89-7867-F1ED-CD07D54BD796}"/>
-              </a:ext>
-            </a:extLst>
-          </p:cNvPr>
-          <p:cNvCxnSpPr>
-            <a:cxnSpLocks/>
-            <a:stCxn id="13" idx="3"/>
-            <a:endCxn id="14" idx="1"/>
-          </p:cNvCxnSpPr>
-          <p:nvPr/>
-        </p:nvCxnSpPr>
-        <p:spPr>
-          <a:xfrm>
-            <a:off x="6356681" y="3429000"/>
-            <a:ext cx="441156" cy="0"/>
-          </a:xfrm>
-          <a:prstGeom prst="straightConnector1">
-            <a:avLst/>
-          </a:prstGeom>
-          <a:ln>
-            <a:tailEnd type="triangle"/>
-          </a:ln>
-        </p:spPr>
-        <p:style>
-          <a:lnRef idx="1">
-            <a:schemeClr val="accent1"/>
-          </a:lnRef>
-          <a:fillRef idx="0">
-            <a:schemeClr val="accent1"/>
-          </a:fillRef>
-          <a:effectRef idx="0">
-            <a:schemeClr val="accent1"/>
-          </a:effectRef>
-          <a:fontRef idx="minor">
-            <a:schemeClr val="tx1"/>
-          </a:fontRef>
-        </p:style>
-      </p:cxnSp>
-      <p:cxnSp>
-        <p:nvCxnSpPr>
-          <p:cNvPr id="32" name="Straight Arrow Connector 31">
-            <a:extLst>
-              <a:ext uri="{FF2B5EF4-FFF2-40B4-BE49-F238E27FC236}">
-                <a16:creationId xmlns:a16="http://schemas.microsoft.com/office/drawing/2014/main" id="{827989C4-B8DC-9ED7-587C-D8DCF7CE901F}"/>
-              </a:ext>
-            </a:extLst>
-          </p:cNvPr>
-          <p:cNvCxnSpPr>
-            <a:cxnSpLocks/>
-            <a:stCxn id="14" idx="3"/>
-            <a:endCxn id="5" idx="1"/>
-          </p:cNvCxnSpPr>
-          <p:nvPr/>
-        </p:nvCxnSpPr>
-        <p:spPr>
-          <a:xfrm>
-            <a:off x="8169437" y="3429000"/>
-            <a:ext cx="453190" cy="0"/>
-          </a:xfrm>
-          <a:prstGeom prst="straightConnector1">
-            <a:avLst/>
-          </a:prstGeom>
-          <a:ln>
-            <a:tailEnd type="triangle"/>
-          </a:ln>
-        </p:spPr>
-        <p:style>
-          <a:lnRef idx="1">
-            <a:schemeClr val="accent1"/>
-          </a:lnRef>
-          <a:fillRef idx="0">
-            <a:schemeClr val="accent1"/>
-          </a:fillRef>
-          <a:effectRef idx="0">
-            <a:schemeClr val="accent1"/>
-          </a:effectRef>
-          <a:fontRef idx="minor">
-            <a:schemeClr val="tx1"/>
-          </a:fontRef>
-        </p:style>
-      </p:cxnSp>
-      <p:cxnSp>
-        <p:nvCxnSpPr>
-          <p:cNvPr id="33" name="Straight Arrow Connector 32">
-            <a:extLst>
-              <a:ext uri="{FF2B5EF4-FFF2-40B4-BE49-F238E27FC236}">
-                <a16:creationId xmlns:a16="http://schemas.microsoft.com/office/drawing/2014/main" id="{4C7B2C1B-DEC8-CBF1-54C6-8CF4885B6257}"/>
-              </a:ext>
-            </a:extLst>
-          </p:cNvPr>
-          <p:cNvCxnSpPr>
-            <a:cxnSpLocks/>
-            <a:stCxn id="5" idx="3"/>
-            <a:endCxn id="15" idx="1"/>
-          </p:cNvCxnSpPr>
-          <p:nvPr/>
-        </p:nvCxnSpPr>
-        <p:spPr>
-          <a:xfrm flipV="1">
-            <a:off x="9994227" y="3416969"/>
-            <a:ext cx="453190" cy="12031"/>
-          </a:xfrm>
-          <a:prstGeom prst="straightConnector1">
-            <a:avLst/>
-          </a:prstGeom>
-          <a:ln>
-            <a:tailEnd type="triangle"/>
-          </a:ln>
-        </p:spPr>
-        <p:style>
-          <a:lnRef idx="1">
-            <a:schemeClr val="accent1"/>
-          </a:lnRef>
-          <a:fillRef idx="0">
-            <a:schemeClr val="accent1"/>
-          </a:fillRef>
-          <a:effectRef idx="0">
-            <a:schemeClr val="accent1"/>
-          </a:effectRef>
-          <a:fontRef idx="minor">
-            <a:schemeClr val="tx1"/>
-          </a:fontRef>
-        </p:style>
-      </p:cxnSp>
-      <p:cxnSp>
-        <p:nvCxnSpPr>
-          <p:cNvPr id="34" name="Straight Arrow Connector 33">
-            <a:extLst>
-              <a:ext uri="{FF2B5EF4-FFF2-40B4-BE49-F238E27FC236}">
-                <a16:creationId xmlns:a16="http://schemas.microsoft.com/office/drawing/2014/main" id="{633287D4-3AAB-0059-CEDB-EF9A583165EE}"/>
-              </a:ext>
-            </a:extLst>
-          </p:cNvPr>
-          <p:cNvCxnSpPr>
-            <a:cxnSpLocks/>
-            <a:stCxn id="6" idx="3"/>
-            <a:endCxn id="9" idx="1"/>
-          </p:cNvCxnSpPr>
-          <p:nvPr/>
-        </p:nvCxnSpPr>
-        <p:spPr>
-          <a:xfrm>
-            <a:off x="2703084" y="4788568"/>
-            <a:ext cx="445173" cy="0"/>
-          </a:xfrm>
-          <a:prstGeom prst="straightConnector1">
-            <a:avLst/>
-          </a:prstGeom>
-          <a:ln>
-            <a:tailEnd type="triangle"/>
-          </a:ln>
-        </p:spPr>
-        <p:style>
-          <a:lnRef idx="1">
-            <a:schemeClr val="accent1"/>
-          </a:lnRef>
-          <a:fillRef idx="0">
-            <a:schemeClr val="accent1"/>
-          </a:fillRef>
-          <a:effectRef idx="0">
-            <a:schemeClr val="accent1"/>
-          </a:effectRef>
-          <a:fontRef idx="minor">
-            <a:schemeClr val="tx1"/>
-          </a:fontRef>
-        </p:style>
-      </p:cxnSp>
-      <p:cxnSp>
-        <p:nvCxnSpPr>
-          <p:cNvPr id="44" name="Connector: Elbow 43">
-            <a:extLst>
-              <a:ext uri="{FF2B5EF4-FFF2-40B4-BE49-F238E27FC236}">
-                <a16:creationId xmlns:a16="http://schemas.microsoft.com/office/drawing/2014/main" id="{D5C0709F-843C-7833-76AF-7BEDD2589789}"/>
-              </a:ext>
-            </a:extLst>
-          </p:cNvPr>
-          <p:cNvCxnSpPr>
-            <a:cxnSpLocks/>
-            <a:stCxn id="15" idx="3"/>
-            <a:endCxn id="64" idx="1"/>
-          </p:cNvCxnSpPr>
-          <p:nvPr/>
-        </p:nvCxnSpPr>
-        <p:spPr>
-          <a:xfrm flipH="1">
-            <a:off x="1311433" y="3416969"/>
-            <a:ext cx="10507584" cy="222584"/>
-          </a:xfrm>
-          <a:prstGeom prst="bentConnector5">
-            <a:avLst>
-              <a:gd name="adj1" fmla="val -916"/>
-              <a:gd name="adj2" fmla="val 281081"/>
-              <a:gd name="adj3" fmla="val 102062"/>
-            </a:avLst>
-          </a:prstGeom>
-          <a:ln>
-            <a:tailEnd type="triangle"/>
-          </a:ln>
-        </p:spPr>
-        <p:style>
-          <a:lnRef idx="1">
-            <a:schemeClr val="accent1"/>
-          </a:lnRef>
-          <a:fillRef idx="0">
-            <a:schemeClr val="accent1"/>
-          </a:fillRef>
-          <a:effectRef idx="0">
-            <a:schemeClr val="accent1"/>
-          </a:effectRef>
-          <a:fontRef idx="minor">
-            <a:schemeClr val="tx1"/>
-          </a:fontRef>
-        </p:style>
-      </p:cxnSp>
-      <p:cxnSp>
-        <p:nvCxnSpPr>
-          <p:cNvPr id="48" name="Connector: Elbow 47">
-            <a:extLst>
-              <a:ext uri="{FF2B5EF4-FFF2-40B4-BE49-F238E27FC236}">
-                <a16:creationId xmlns:a16="http://schemas.microsoft.com/office/drawing/2014/main" id="{709AAFB2-35BE-DAA2-DB3D-52742B0BEAEB}"/>
-              </a:ext>
-            </a:extLst>
-          </p:cNvPr>
-          <p:cNvCxnSpPr>
-            <a:cxnSpLocks/>
-            <a:stCxn id="15" idx="3"/>
-            <a:endCxn id="6" idx="1"/>
-          </p:cNvCxnSpPr>
-          <p:nvPr/>
-        </p:nvCxnSpPr>
-        <p:spPr>
-          <a:xfrm flipH="1">
-            <a:off x="1331484" y="3416969"/>
-            <a:ext cx="10487533" cy="1371599"/>
-          </a:xfrm>
-          <a:prstGeom prst="bentConnector5">
-            <a:avLst>
-              <a:gd name="adj1" fmla="val -1950"/>
-              <a:gd name="adj2" fmla="val 54386"/>
-              <a:gd name="adj3" fmla="val 102294"/>
-            </a:avLst>
-          </a:prstGeom>
-          <a:ln>
-            <a:tailEnd type="triangle"/>
-          </a:ln>
-        </p:spPr>
-        <p:style>
-          <a:lnRef idx="1">
-            <a:schemeClr val="accent1"/>
-          </a:lnRef>
-          <a:fillRef idx="0">
-            <a:schemeClr val="accent1"/>
-          </a:fillRef>
-          <a:effectRef idx="0">
-            <a:schemeClr val="accent1"/>
-          </a:effectRef>
-          <a:fontRef idx="minor">
-            <a:schemeClr val="tx1"/>
-          </a:fontRef>
-        </p:style>
-      </p:cxnSp>
-      <p:sp>
-        <p:nvSpPr>
-          <p:cNvPr id="82" name="Title 81">
-            <a:extLst>
-              <a:ext uri="{FF2B5EF4-FFF2-40B4-BE49-F238E27FC236}">
-                <a16:creationId xmlns:a16="http://schemas.microsoft.com/office/drawing/2014/main" id="{F611047F-9E5C-BA0B-EF6A-58CD914892CD}"/>
-              </a:ext>
-            </a:extLst>
-          </p:cNvPr>
-          <p:cNvSpPr>
-            <a:spLocks noGrp="1"/>
-          </p:cNvSpPr>
-          <p:nvPr>
-            <p:ph type="title"/>
-          </p:nvPr>
-        </p:nvSpPr>
-        <p:spPr/>
-        <p:txBody>
-          <a:bodyPr/>
-          <a:lstStyle/>
-          <a:p>
             <a:pPr algn="ctr"/>
             <a:r>
               <a:rPr lang="en-US" dirty="0"/>
-              <a:t>Modular Agent Architecture</a:t>
+              <a:t>Start</a:t>
             </a:r>
           </a:p>
         </p:txBody>

</xml_diff>

<commit_message>
Updated plots to v6.0
</commit_message>
<xml_diff>
--- a/agent-diagrams.pptx
+++ b/agent-diagrams.pptx
@@ -6,6 +6,7 @@
   </p:sldMasterIdLst>
   <p:sldIdLst>
     <p:sldId id="256" r:id="rId2"/>
+    <p:sldId id="257" r:id="rId3"/>
   </p:sldIdLst>
   <p:sldSz cx="12192000" cy="6858000"/>
   <p:notesSz cx="6858000" cy="9144000"/>
@@ -254,7 +255,7 @@
           <a:p>
             <a:fld id="{7EFC964A-A7A6-4716-9273-3B457FACE4DE}" type="datetimeFigureOut">
               <a:rPr lang="en-US" smtClean="0"/>
-              <a:t>4/9/2026</a:t>
+              <a:t>6/12/2026</a:t>
             </a:fld>
             <a:endParaRPr lang="en-US"/>
           </a:p>
@@ -424,7 +425,7 @@
           <a:p>
             <a:fld id="{7EFC964A-A7A6-4716-9273-3B457FACE4DE}" type="datetimeFigureOut">
               <a:rPr lang="en-US" smtClean="0"/>
-              <a:t>4/9/2026</a:t>
+              <a:t>6/12/2026</a:t>
             </a:fld>
             <a:endParaRPr lang="en-US"/>
           </a:p>
@@ -604,7 +605,7 @@
           <a:p>
             <a:fld id="{7EFC964A-A7A6-4716-9273-3B457FACE4DE}" type="datetimeFigureOut">
               <a:rPr lang="en-US" smtClean="0"/>
-              <a:t>4/9/2026</a:t>
+              <a:t>6/12/2026</a:t>
             </a:fld>
             <a:endParaRPr lang="en-US"/>
           </a:p>
@@ -774,7 +775,7 @@
           <a:p>
             <a:fld id="{7EFC964A-A7A6-4716-9273-3B457FACE4DE}" type="datetimeFigureOut">
               <a:rPr lang="en-US" smtClean="0"/>
-              <a:t>4/9/2026</a:t>
+              <a:t>6/12/2026</a:t>
             </a:fld>
             <a:endParaRPr lang="en-US"/>
           </a:p>
@@ -1020,7 +1021,7 @@
           <a:p>
             <a:fld id="{7EFC964A-A7A6-4716-9273-3B457FACE4DE}" type="datetimeFigureOut">
               <a:rPr lang="en-US" smtClean="0"/>
-              <a:t>4/9/2026</a:t>
+              <a:t>6/12/2026</a:t>
             </a:fld>
             <a:endParaRPr lang="en-US"/>
           </a:p>
@@ -1252,7 +1253,7 @@
           <a:p>
             <a:fld id="{7EFC964A-A7A6-4716-9273-3B457FACE4DE}" type="datetimeFigureOut">
               <a:rPr lang="en-US" smtClean="0"/>
-              <a:t>4/9/2026</a:t>
+              <a:t>6/12/2026</a:t>
             </a:fld>
             <a:endParaRPr lang="en-US"/>
           </a:p>
@@ -1619,7 +1620,7 @@
           <a:p>
             <a:fld id="{7EFC964A-A7A6-4716-9273-3B457FACE4DE}" type="datetimeFigureOut">
               <a:rPr lang="en-US" smtClean="0"/>
-              <a:t>4/9/2026</a:t>
+              <a:t>6/12/2026</a:t>
             </a:fld>
             <a:endParaRPr lang="en-US"/>
           </a:p>
@@ -1737,7 +1738,7 @@
           <a:p>
             <a:fld id="{7EFC964A-A7A6-4716-9273-3B457FACE4DE}" type="datetimeFigureOut">
               <a:rPr lang="en-US" smtClean="0"/>
-              <a:t>4/9/2026</a:t>
+              <a:t>6/12/2026</a:t>
             </a:fld>
             <a:endParaRPr lang="en-US"/>
           </a:p>
@@ -1832,7 +1833,7 @@
           <a:p>
             <a:fld id="{7EFC964A-A7A6-4716-9273-3B457FACE4DE}" type="datetimeFigureOut">
               <a:rPr lang="en-US" smtClean="0"/>
-              <a:t>4/9/2026</a:t>
+              <a:t>6/12/2026</a:t>
             </a:fld>
             <a:endParaRPr lang="en-US"/>
           </a:p>
@@ -2109,7 +2110,7 @@
           <a:p>
             <a:fld id="{7EFC964A-A7A6-4716-9273-3B457FACE4DE}" type="datetimeFigureOut">
               <a:rPr lang="en-US" smtClean="0"/>
-              <a:t>4/9/2026</a:t>
+              <a:t>6/12/2026</a:t>
             </a:fld>
             <a:endParaRPr lang="en-US"/>
           </a:p>
@@ -2366,7 +2367,7 @@
           <a:p>
             <a:fld id="{7EFC964A-A7A6-4716-9273-3B457FACE4DE}" type="datetimeFigureOut">
               <a:rPr lang="en-US" smtClean="0"/>
-              <a:t>4/9/2026</a:t>
+              <a:t>6/12/2026</a:t>
             </a:fld>
             <a:endParaRPr lang="en-US"/>
           </a:p>
@@ -2579,7 +2580,7 @@
           <a:p>
             <a:fld id="{7EFC964A-A7A6-4716-9273-3B457FACE4DE}" type="datetimeFigureOut">
               <a:rPr lang="en-US" smtClean="0"/>
-              <a:t>4/9/2026</a:t>
+              <a:t>6/12/2026</a:t>
             </a:fld>
             <a:endParaRPr lang="en-US"/>
           </a:p>
@@ -3961,6 +3962,961 @@
 </p:sld>
 </file>
 
+<file path=ppt/slides/slide2.xml><?xml version="1.0" encoding="utf-8"?>
+<p:sld xmlns:a="http://schemas.openxmlformats.org/drawingml/2006/main" xmlns:r="http://schemas.openxmlformats.org/officeDocument/2006/relationships" xmlns:p="http://schemas.openxmlformats.org/presentationml/2006/main">
+  <p:cSld>
+    <p:spTree>
+      <p:nvGrpSpPr>
+        <p:cNvPr id="1" name="">
+          <a:extLst>
+            <a:ext uri="{FF2B5EF4-FFF2-40B4-BE49-F238E27FC236}">
+              <a16:creationId xmlns:a16="http://schemas.microsoft.com/office/drawing/2014/main" id="{ADF3ABBB-A5EB-087F-7CDB-67D758DFF27C}"/>
+            </a:ext>
+          </a:extLst>
+        </p:cNvPr>
+        <p:cNvGrpSpPr/>
+        <p:nvPr/>
+      </p:nvGrpSpPr>
+      <p:grpSpPr>
+        <a:xfrm>
+          <a:off x="0" y="0"/>
+          <a:ext cx="0" cy="0"/>
+          <a:chOff x="0" y="0"/>
+          <a:chExt cx="0" cy="0"/>
+        </a:xfrm>
+      </p:grpSpPr>
+      <p:sp>
+        <p:nvSpPr>
+          <p:cNvPr id="6" name="Rectangle: Rounded Corners 5">
+            <a:extLst>
+              <a:ext uri="{FF2B5EF4-FFF2-40B4-BE49-F238E27FC236}">
+                <a16:creationId xmlns:a16="http://schemas.microsoft.com/office/drawing/2014/main" id="{5C63707F-6762-DA46-8024-8E18474651BA}"/>
+              </a:ext>
+            </a:extLst>
+          </p:cNvPr>
+          <p:cNvSpPr/>
+          <p:nvPr/>
+        </p:nvSpPr>
+        <p:spPr>
+          <a:xfrm>
+            <a:off x="7181863" y="3210033"/>
+            <a:ext cx="1374042" cy="687021"/>
+          </a:xfrm>
+          <a:prstGeom prst="roundRect">
+            <a:avLst/>
+          </a:prstGeom>
+          <a:solidFill>
+            <a:schemeClr val="accent5"/>
+          </a:solidFill>
+          <a:ln>
+            <a:noFill/>
+          </a:ln>
+        </p:spPr>
+        <p:style>
+          <a:lnRef idx="2">
+            <a:schemeClr val="accent1">
+              <a:shade val="15000"/>
+            </a:schemeClr>
+          </a:lnRef>
+          <a:fillRef idx="1">
+            <a:schemeClr val="accent1"/>
+          </a:fillRef>
+          <a:effectRef idx="0">
+            <a:schemeClr val="accent1"/>
+          </a:effectRef>
+          <a:fontRef idx="minor">
+            <a:schemeClr val="lt1"/>
+          </a:fontRef>
+        </p:style>
+        <p:txBody>
+          <a:bodyPr rtlCol="0" anchor="ctr"/>
+          <a:lstStyle/>
+          <a:p>
+            <a:pPr algn="ctr"/>
+            <a:r>
+              <a:rPr lang="en-US" dirty="0"/>
+              <a:t>Reasoner</a:t>
+            </a:r>
+          </a:p>
+        </p:txBody>
+      </p:sp>
+      <p:sp>
+        <p:nvSpPr>
+          <p:cNvPr id="9" name="Rectangle: Rounded Corners 8">
+            <a:extLst>
+              <a:ext uri="{FF2B5EF4-FFF2-40B4-BE49-F238E27FC236}">
+                <a16:creationId xmlns:a16="http://schemas.microsoft.com/office/drawing/2014/main" id="{09D1BA3D-716F-193A-9F69-6AEC43977C47}"/>
+              </a:ext>
+            </a:extLst>
+          </p:cNvPr>
+          <p:cNvSpPr/>
+          <p:nvPr/>
+        </p:nvSpPr>
+        <p:spPr>
+          <a:xfrm>
+            <a:off x="3425022" y="2741979"/>
+            <a:ext cx="1374042" cy="687021"/>
+          </a:xfrm>
+          <a:prstGeom prst="roundRect">
+            <a:avLst/>
+          </a:prstGeom>
+          <a:solidFill>
+            <a:schemeClr val="accent5"/>
+          </a:solidFill>
+          <a:ln>
+            <a:noFill/>
+          </a:ln>
+        </p:spPr>
+        <p:style>
+          <a:lnRef idx="2">
+            <a:schemeClr val="accent1">
+              <a:shade val="15000"/>
+            </a:schemeClr>
+          </a:lnRef>
+          <a:fillRef idx="1">
+            <a:schemeClr val="accent1"/>
+          </a:fillRef>
+          <a:effectRef idx="0">
+            <a:schemeClr val="accent1"/>
+          </a:effectRef>
+          <a:fontRef idx="minor">
+            <a:schemeClr val="lt1"/>
+          </a:fontRef>
+        </p:style>
+        <p:txBody>
+          <a:bodyPr rtlCol="0" anchor="ctr"/>
+          <a:lstStyle/>
+          <a:p>
+            <a:pPr algn="ctr"/>
+            <a:r>
+              <a:rPr lang="en-US" dirty="0"/>
+              <a:t>Summarizer</a:t>
+            </a:r>
+          </a:p>
+        </p:txBody>
+      </p:sp>
+      <p:sp>
+        <p:nvSpPr>
+          <p:cNvPr id="11" name="Rectangle: Rounded Corners 10">
+            <a:extLst>
+              <a:ext uri="{FF2B5EF4-FFF2-40B4-BE49-F238E27FC236}">
+                <a16:creationId xmlns:a16="http://schemas.microsoft.com/office/drawing/2014/main" id="{08E2075E-7C75-6EE0-5028-9CC11B755437}"/>
+              </a:ext>
+            </a:extLst>
+          </p:cNvPr>
+          <p:cNvSpPr/>
+          <p:nvPr/>
+        </p:nvSpPr>
+        <p:spPr>
+          <a:xfrm>
+            <a:off x="5303450" y="3210034"/>
+            <a:ext cx="1374039" cy="687021"/>
+          </a:xfrm>
+          <a:prstGeom prst="roundRect">
+            <a:avLst/>
+          </a:prstGeom>
+          <a:solidFill>
+            <a:schemeClr val="accent5"/>
+          </a:solidFill>
+          <a:ln>
+            <a:noFill/>
+          </a:ln>
+        </p:spPr>
+        <p:style>
+          <a:lnRef idx="2">
+            <a:schemeClr val="accent1">
+              <a:shade val="15000"/>
+            </a:schemeClr>
+          </a:lnRef>
+          <a:fillRef idx="1">
+            <a:schemeClr val="accent1"/>
+          </a:fillRef>
+          <a:effectRef idx="0">
+            <a:schemeClr val="accent1"/>
+          </a:effectRef>
+          <a:fontRef idx="minor">
+            <a:schemeClr val="lt1"/>
+          </a:fontRef>
+        </p:style>
+        <p:txBody>
+          <a:bodyPr rtlCol="0" anchor="ctr"/>
+          <a:lstStyle/>
+          <a:p>
+            <a:pPr algn="ctr"/>
+            <a:r>
+              <a:rPr lang="en-US" dirty="0"/>
+              <a:t>Planner</a:t>
+            </a:r>
+          </a:p>
+        </p:txBody>
+      </p:sp>
+      <p:sp>
+        <p:nvSpPr>
+          <p:cNvPr id="12" name="Rectangle: Rounded Corners 11">
+            <a:extLst>
+              <a:ext uri="{FF2B5EF4-FFF2-40B4-BE49-F238E27FC236}">
+                <a16:creationId xmlns:a16="http://schemas.microsoft.com/office/drawing/2014/main" id="{C52EA59F-4C80-24D4-D508-BC768CB4FE59}"/>
+              </a:ext>
+            </a:extLst>
+          </p:cNvPr>
+          <p:cNvSpPr/>
+          <p:nvPr/>
+        </p:nvSpPr>
+        <p:spPr>
+          <a:xfrm>
+            <a:off x="3425018" y="3611269"/>
+            <a:ext cx="1374036" cy="687021"/>
+          </a:xfrm>
+          <a:prstGeom prst="roundRect">
+            <a:avLst/>
+          </a:prstGeom>
+          <a:solidFill>
+            <a:schemeClr val="accent5"/>
+          </a:solidFill>
+          <a:ln>
+            <a:noFill/>
+          </a:ln>
+        </p:spPr>
+        <p:style>
+          <a:lnRef idx="2">
+            <a:schemeClr val="accent1">
+              <a:shade val="15000"/>
+            </a:schemeClr>
+          </a:lnRef>
+          <a:fillRef idx="1">
+            <a:schemeClr val="accent1"/>
+          </a:fillRef>
+          <a:effectRef idx="0">
+            <a:schemeClr val="accent1"/>
+          </a:effectRef>
+          <a:fontRef idx="minor">
+            <a:schemeClr val="lt1"/>
+          </a:fontRef>
+        </p:style>
+        <p:txBody>
+          <a:bodyPr rtlCol="0" anchor="ctr"/>
+          <a:lstStyle/>
+          <a:p>
+            <a:pPr algn="ctr"/>
+            <a:r>
+              <a:rPr lang="en-US" dirty="0"/>
+              <a:t>Memorizer</a:t>
+            </a:r>
+          </a:p>
+        </p:txBody>
+      </p:sp>
+      <p:sp>
+        <p:nvSpPr>
+          <p:cNvPr id="13" name="Rectangle: Rounded Corners 12">
+            <a:extLst>
+              <a:ext uri="{FF2B5EF4-FFF2-40B4-BE49-F238E27FC236}">
+                <a16:creationId xmlns:a16="http://schemas.microsoft.com/office/drawing/2014/main" id="{38B176A9-5603-8792-7BEC-2493A6E162D4}"/>
+              </a:ext>
+            </a:extLst>
+          </p:cNvPr>
+          <p:cNvSpPr/>
+          <p:nvPr/>
+        </p:nvSpPr>
+        <p:spPr>
+          <a:xfrm>
+            <a:off x="9060276" y="3196904"/>
+            <a:ext cx="1374042" cy="687021"/>
+          </a:xfrm>
+          <a:prstGeom prst="roundRect">
+            <a:avLst/>
+          </a:prstGeom>
+          <a:solidFill>
+            <a:schemeClr val="accent5"/>
+          </a:solidFill>
+          <a:ln>
+            <a:noFill/>
+          </a:ln>
+        </p:spPr>
+        <p:style>
+          <a:lnRef idx="2">
+            <a:schemeClr val="accent1">
+              <a:shade val="15000"/>
+            </a:schemeClr>
+          </a:lnRef>
+          <a:fillRef idx="1">
+            <a:schemeClr val="accent1"/>
+          </a:fillRef>
+          <a:effectRef idx="0">
+            <a:schemeClr val="accent1"/>
+          </a:effectRef>
+          <a:fontRef idx="minor">
+            <a:schemeClr val="lt1"/>
+          </a:fontRef>
+        </p:style>
+        <p:txBody>
+          <a:bodyPr rtlCol="0" anchor="ctr"/>
+          <a:lstStyle/>
+          <a:p>
+            <a:pPr algn="ctr"/>
+            <a:r>
+              <a:rPr lang="en-US" dirty="0"/>
+              <a:t>Actor</a:t>
+            </a:r>
+          </a:p>
+        </p:txBody>
+      </p:sp>
+      <p:cxnSp>
+        <p:nvCxnSpPr>
+          <p:cNvPr id="19" name="Straight Arrow Connector 18">
+            <a:extLst>
+              <a:ext uri="{FF2B5EF4-FFF2-40B4-BE49-F238E27FC236}">
+                <a16:creationId xmlns:a16="http://schemas.microsoft.com/office/drawing/2014/main" id="{B8FE5BB5-E3B6-B91D-B208-BC7DC412E43F}"/>
+              </a:ext>
+            </a:extLst>
+          </p:cNvPr>
+          <p:cNvCxnSpPr>
+            <a:cxnSpLocks/>
+            <a:stCxn id="6" idx="3"/>
+            <a:endCxn id="13" idx="1"/>
+          </p:cNvCxnSpPr>
+          <p:nvPr/>
+        </p:nvCxnSpPr>
+        <p:spPr>
+          <a:xfrm flipV="1">
+            <a:off x="8555905" y="3540415"/>
+            <a:ext cx="504371" cy="13129"/>
+          </a:xfrm>
+          <a:prstGeom prst="straightConnector1">
+            <a:avLst/>
+          </a:prstGeom>
+          <a:ln w="38100">
+            <a:solidFill>
+              <a:schemeClr val="accent3"/>
+            </a:solidFill>
+            <a:tailEnd type="triangle"/>
+          </a:ln>
+        </p:spPr>
+        <p:style>
+          <a:lnRef idx="1">
+            <a:schemeClr val="accent1"/>
+          </a:lnRef>
+          <a:fillRef idx="0">
+            <a:schemeClr val="accent1"/>
+          </a:fillRef>
+          <a:effectRef idx="0">
+            <a:schemeClr val="accent1"/>
+          </a:effectRef>
+          <a:fontRef idx="minor">
+            <a:schemeClr val="tx1"/>
+          </a:fontRef>
+        </p:style>
+      </p:cxnSp>
+      <p:sp>
+        <p:nvSpPr>
+          <p:cNvPr id="27" name="Rectangle: Rounded Corners 26">
+            <a:extLst>
+              <a:ext uri="{FF2B5EF4-FFF2-40B4-BE49-F238E27FC236}">
+                <a16:creationId xmlns:a16="http://schemas.microsoft.com/office/drawing/2014/main" id="{72370DBD-FD07-D99A-22AD-F5526DD3F541}"/>
+              </a:ext>
+            </a:extLst>
+          </p:cNvPr>
+          <p:cNvSpPr/>
+          <p:nvPr/>
+        </p:nvSpPr>
+        <p:spPr>
+          <a:xfrm>
+            <a:off x="1546592" y="3196907"/>
+            <a:ext cx="1374042" cy="687021"/>
+          </a:xfrm>
+          <a:prstGeom prst="roundRect">
+            <a:avLst/>
+          </a:prstGeom>
+          <a:solidFill>
+            <a:schemeClr val="accent6"/>
+          </a:solidFill>
+          <a:ln>
+            <a:noFill/>
+          </a:ln>
+        </p:spPr>
+        <p:style>
+          <a:lnRef idx="2">
+            <a:schemeClr val="accent1">
+              <a:shade val="15000"/>
+            </a:schemeClr>
+          </a:lnRef>
+          <a:fillRef idx="1">
+            <a:schemeClr val="accent1"/>
+          </a:fillRef>
+          <a:effectRef idx="0">
+            <a:schemeClr val="accent1"/>
+          </a:effectRef>
+          <a:fontRef idx="minor">
+            <a:schemeClr val="lt1"/>
+          </a:fontRef>
+        </p:style>
+        <p:txBody>
+          <a:bodyPr lIns="0" tIns="0" rIns="0" bIns="0" rtlCol="0" anchor="ctr"/>
+          <a:lstStyle/>
+          <a:p>
+            <a:pPr algn="ctr"/>
+            <a:r>
+              <a:rPr lang="en-US" dirty="0"/>
+              <a:t>Environment</a:t>
+            </a:r>
+          </a:p>
+        </p:txBody>
+      </p:sp>
+      <p:cxnSp>
+        <p:nvCxnSpPr>
+          <p:cNvPr id="30" name="Connector: Elbow 29">
+            <a:extLst>
+              <a:ext uri="{FF2B5EF4-FFF2-40B4-BE49-F238E27FC236}">
+                <a16:creationId xmlns:a16="http://schemas.microsoft.com/office/drawing/2014/main" id="{90EB27EB-1671-8A9A-FBC4-183C4B63D04B}"/>
+              </a:ext>
+            </a:extLst>
+          </p:cNvPr>
+          <p:cNvCxnSpPr>
+            <a:cxnSpLocks/>
+            <a:stCxn id="27" idx="3"/>
+            <a:endCxn id="12" idx="1"/>
+          </p:cNvCxnSpPr>
+          <p:nvPr/>
+        </p:nvCxnSpPr>
+        <p:spPr>
+          <a:xfrm>
+            <a:off x="2920634" y="3540418"/>
+            <a:ext cx="504384" cy="414362"/>
+          </a:xfrm>
+          <a:prstGeom prst="bentConnector3">
+            <a:avLst>
+              <a:gd name="adj1" fmla="val 50000"/>
+            </a:avLst>
+          </a:prstGeom>
+          <a:ln w="38100">
+            <a:solidFill>
+              <a:schemeClr val="accent3"/>
+            </a:solidFill>
+            <a:tailEnd type="triangle"/>
+          </a:ln>
+        </p:spPr>
+        <p:style>
+          <a:lnRef idx="1">
+            <a:schemeClr val="accent1"/>
+          </a:lnRef>
+          <a:fillRef idx="0">
+            <a:schemeClr val="accent1"/>
+          </a:fillRef>
+          <a:effectRef idx="0">
+            <a:schemeClr val="accent1"/>
+          </a:effectRef>
+          <a:fontRef idx="minor">
+            <a:schemeClr val="tx1"/>
+          </a:fontRef>
+        </p:style>
+      </p:cxnSp>
+      <p:cxnSp>
+        <p:nvCxnSpPr>
+          <p:cNvPr id="32" name="Straight Arrow Connector 31">
+            <a:extLst>
+              <a:ext uri="{FF2B5EF4-FFF2-40B4-BE49-F238E27FC236}">
+                <a16:creationId xmlns:a16="http://schemas.microsoft.com/office/drawing/2014/main" id="{5DBB06D9-02F9-EF61-F145-27D6D603A896}"/>
+              </a:ext>
+            </a:extLst>
+          </p:cNvPr>
+          <p:cNvCxnSpPr>
+            <a:cxnSpLocks/>
+            <a:stCxn id="33" idx="4"/>
+            <a:endCxn id="27" idx="0"/>
+          </p:cNvCxnSpPr>
+          <p:nvPr/>
+        </p:nvCxnSpPr>
+        <p:spPr>
+          <a:xfrm>
+            <a:off x="2233613" y="2834908"/>
+            <a:ext cx="0" cy="361999"/>
+          </a:xfrm>
+          <a:prstGeom prst="straightConnector1">
+            <a:avLst/>
+          </a:prstGeom>
+          <a:ln w="38100">
+            <a:solidFill>
+              <a:schemeClr val="accent3"/>
+            </a:solidFill>
+            <a:tailEnd type="triangle"/>
+          </a:ln>
+        </p:spPr>
+        <p:style>
+          <a:lnRef idx="1">
+            <a:schemeClr val="accent1"/>
+          </a:lnRef>
+          <a:fillRef idx="0">
+            <a:schemeClr val="accent1"/>
+          </a:fillRef>
+          <a:effectRef idx="0">
+            <a:schemeClr val="accent1"/>
+          </a:effectRef>
+          <a:fontRef idx="minor">
+            <a:schemeClr val="tx1"/>
+          </a:fontRef>
+        </p:style>
+      </p:cxnSp>
+      <p:sp>
+        <p:nvSpPr>
+          <p:cNvPr id="33" name="Oval 32">
+            <a:extLst>
+              <a:ext uri="{FF2B5EF4-FFF2-40B4-BE49-F238E27FC236}">
+                <a16:creationId xmlns:a16="http://schemas.microsoft.com/office/drawing/2014/main" id="{F4FC5A78-EBF9-30FD-274A-53FACBB34A4B}"/>
+              </a:ext>
+            </a:extLst>
+          </p:cNvPr>
+          <p:cNvSpPr/>
+          <p:nvPr/>
+        </p:nvSpPr>
+        <p:spPr>
+          <a:xfrm>
+            <a:off x="1890102" y="2147887"/>
+            <a:ext cx="687021" cy="687021"/>
+          </a:xfrm>
+          <a:prstGeom prst="ellipse">
+            <a:avLst/>
+          </a:prstGeom>
+          <a:solidFill>
+            <a:schemeClr val="accent3"/>
+          </a:solidFill>
+          <a:ln>
+            <a:noFill/>
+          </a:ln>
+        </p:spPr>
+        <p:style>
+          <a:lnRef idx="2">
+            <a:schemeClr val="accent1">
+              <a:shade val="15000"/>
+            </a:schemeClr>
+          </a:lnRef>
+          <a:fillRef idx="1">
+            <a:schemeClr val="accent1"/>
+          </a:fillRef>
+          <a:effectRef idx="0">
+            <a:schemeClr val="accent1"/>
+          </a:effectRef>
+          <a:fontRef idx="minor">
+            <a:schemeClr val="lt1"/>
+          </a:fontRef>
+        </p:style>
+        <p:txBody>
+          <a:bodyPr lIns="0" tIns="0" rIns="0" bIns="0" rtlCol="0" anchor="ctr"/>
+          <a:lstStyle/>
+          <a:p>
+            <a:pPr algn="ctr"/>
+            <a:r>
+              <a:rPr lang="en-US" sz="1400" dirty="0"/>
+              <a:t>Start</a:t>
+            </a:r>
+          </a:p>
+        </p:txBody>
+      </p:sp>
+      <p:sp>
+        <p:nvSpPr>
+          <p:cNvPr id="34" name="Oval 33">
+            <a:extLst>
+              <a:ext uri="{FF2B5EF4-FFF2-40B4-BE49-F238E27FC236}">
+                <a16:creationId xmlns:a16="http://schemas.microsoft.com/office/drawing/2014/main" id="{27517CAB-367E-C5F3-A8E9-390D41DFD131}"/>
+              </a:ext>
+            </a:extLst>
+          </p:cNvPr>
+          <p:cNvSpPr/>
+          <p:nvPr/>
+        </p:nvSpPr>
+        <p:spPr>
+          <a:xfrm>
+            <a:off x="1890102" y="4245926"/>
+            <a:ext cx="687021" cy="687021"/>
+          </a:xfrm>
+          <a:prstGeom prst="ellipse">
+            <a:avLst/>
+          </a:prstGeom>
+          <a:solidFill>
+            <a:schemeClr val="accent3"/>
+          </a:solidFill>
+          <a:ln>
+            <a:noFill/>
+          </a:ln>
+        </p:spPr>
+        <p:style>
+          <a:lnRef idx="2">
+            <a:schemeClr val="accent1">
+              <a:shade val="15000"/>
+            </a:schemeClr>
+          </a:lnRef>
+          <a:fillRef idx="1">
+            <a:schemeClr val="accent1"/>
+          </a:fillRef>
+          <a:effectRef idx="0">
+            <a:schemeClr val="accent1"/>
+          </a:effectRef>
+          <a:fontRef idx="minor">
+            <a:schemeClr val="lt1"/>
+          </a:fontRef>
+        </p:style>
+        <p:txBody>
+          <a:bodyPr lIns="0" tIns="0" rIns="0" bIns="0" rtlCol="0" anchor="ctr"/>
+          <a:lstStyle/>
+          <a:p>
+            <a:pPr algn="ctr"/>
+            <a:r>
+              <a:rPr lang="en-US" sz="1400" dirty="0"/>
+              <a:t>End</a:t>
+            </a:r>
+          </a:p>
+        </p:txBody>
+      </p:sp>
+      <p:cxnSp>
+        <p:nvCxnSpPr>
+          <p:cNvPr id="39" name="Straight Arrow Connector 38">
+            <a:extLst>
+              <a:ext uri="{FF2B5EF4-FFF2-40B4-BE49-F238E27FC236}">
+                <a16:creationId xmlns:a16="http://schemas.microsoft.com/office/drawing/2014/main" id="{E7BBD24E-DE5E-76FE-FDE9-58E37DDBA49C}"/>
+              </a:ext>
+            </a:extLst>
+          </p:cNvPr>
+          <p:cNvCxnSpPr>
+            <a:cxnSpLocks/>
+            <a:stCxn id="27" idx="2"/>
+            <a:endCxn id="34" idx="0"/>
+          </p:cNvCxnSpPr>
+          <p:nvPr/>
+        </p:nvCxnSpPr>
+        <p:spPr>
+          <a:xfrm>
+            <a:off x="2233613" y="3883927"/>
+            <a:ext cx="0" cy="361999"/>
+          </a:xfrm>
+          <a:prstGeom prst="straightConnector1">
+            <a:avLst/>
+          </a:prstGeom>
+          <a:ln w="38100">
+            <a:solidFill>
+              <a:schemeClr val="accent3"/>
+            </a:solidFill>
+            <a:tailEnd type="triangle"/>
+          </a:ln>
+        </p:spPr>
+        <p:style>
+          <a:lnRef idx="1">
+            <a:schemeClr val="accent1"/>
+          </a:lnRef>
+          <a:fillRef idx="0">
+            <a:schemeClr val="accent1"/>
+          </a:fillRef>
+          <a:effectRef idx="0">
+            <a:schemeClr val="accent1"/>
+          </a:effectRef>
+          <a:fontRef idx="minor">
+            <a:schemeClr val="tx1"/>
+          </a:fontRef>
+        </p:style>
+      </p:cxnSp>
+      <p:sp>
+        <p:nvSpPr>
+          <p:cNvPr id="40" name="Title 1">
+            <a:extLst>
+              <a:ext uri="{FF2B5EF4-FFF2-40B4-BE49-F238E27FC236}">
+                <a16:creationId xmlns:a16="http://schemas.microsoft.com/office/drawing/2014/main" id="{8E22C2F8-DEB1-CB74-F6BC-7E94F1D235EB}"/>
+              </a:ext>
+            </a:extLst>
+          </p:cNvPr>
+          <p:cNvSpPr txBox="1">
+            <a:spLocks/>
+          </p:cNvSpPr>
+          <p:nvPr/>
+        </p:nvSpPr>
+        <p:spPr>
+          <a:xfrm>
+            <a:off x="838200" y="365125"/>
+            <a:ext cx="10515600" cy="1325563"/>
+          </a:xfrm>
+          <a:prstGeom prst="rect">
+            <a:avLst/>
+          </a:prstGeom>
+        </p:spPr>
+        <p:txBody>
+          <a:bodyPr vert="horz" lIns="91440" tIns="45720" rIns="91440" bIns="45720" rtlCol="0" anchor="ctr">
+            <a:normAutofit/>
+          </a:bodyPr>
+          <a:lstStyle>
+            <a:lvl1pPr algn="l" defTabSz="914400" rtl="0" eaLnBrk="1" latinLnBrk="0" hangingPunct="1">
+              <a:lnSpc>
+                <a:spcPct val="90000"/>
+              </a:lnSpc>
+              <a:spcBef>
+                <a:spcPct val="0"/>
+              </a:spcBef>
+              <a:buNone/>
+              <a:defRPr sz="4400" kern="1200">
+                <a:solidFill>
+                  <a:schemeClr val="tx1"/>
+                </a:solidFill>
+                <a:latin typeface="+mj-lt"/>
+                <a:ea typeface="+mj-ea"/>
+                <a:cs typeface="+mj-cs"/>
+              </a:defRPr>
+            </a:lvl1pPr>
+          </a:lstStyle>
+          <a:p>
+            <a:pPr algn="ctr"/>
+            <a:r>
+              <a:rPr lang="en-US" dirty="0"/>
+              <a:t>Modular Agent Architecture</a:t>
+            </a:r>
+          </a:p>
+        </p:txBody>
+      </p:sp>
+      <p:cxnSp>
+        <p:nvCxnSpPr>
+          <p:cNvPr id="35" name="Connector: Elbow 34">
+            <a:extLst>
+              <a:ext uri="{FF2B5EF4-FFF2-40B4-BE49-F238E27FC236}">
+                <a16:creationId xmlns:a16="http://schemas.microsoft.com/office/drawing/2014/main" id="{31F5EEA4-7621-AB8E-7FF6-430316A62563}"/>
+              </a:ext>
+            </a:extLst>
+          </p:cNvPr>
+          <p:cNvCxnSpPr>
+            <a:cxnSpLocks/>
+            <a:stCxn id="27" idx="3"/>
+            <a:endCxn id="9" idx="1"/>
+          </p:cNvCxnSpPr>
+          <p:nvPr/>
+        </p:nvCxnSpPr>
+        <p:spPr>
+          <a:xfrm flipV="1">
+            <a:off x="2920634" y="3085490"/>
+            <a:ext cx="504388" cy="454928"/>
+          </a:xfrm>
+          <a:prstGeom prst="bentConnector3">
+            <a:avLst>
+              <a:gd name="adj1" fmla="val 50000"/>
+            </a:avLst>
+          </a:prstGeom>
+          <a:ln w="38100">
+            <a:solidFill>
+              <a:schemeClr val="accent3"/>
+            </a:solidFill>
+            <a:tailEnd type="triangle"/>
+          </a:ln>
+        </p:spPr>
+        <p:style>
+          <a:lnRef idx="1">
+            <a:schemeClr val="accent1"/>
+          </a:lnRef>
+          <a:fillRef idx="0">
+            <a:schemeClr val="accent1"/>
+          </a:fillRef>
+          <a:effectRef idx="0">
+            <a:schemeClr val="accent1"/>
+          </a:effectRef>
+          <a:fontRef idx="minor">
+            <a:schemeClr val="tx1"/>
+          </a:fontRef>
+        </p:style>
+      </p:cxnSp>
+      <p:cxnSp>
+        <p:nvCxnSpPr>
+          <p:cNvPr id="43" name="Connector: Elbow 42">
+            <a:extLst>
+              <a:ext uri="{FF2B5EF4-FFF2-40B4-BE49-F238E27FC236}">
+                <a16:creationId xmlns:a16="http://schemas.microsoft.com/office/drawing/2014/main" id="{0F8280FB-4CCF-F6CB-1FF1-997DEFCD45A1}"/>
+              </a:ext>
+            </a:extLst>
+          </p:cNvPr>
+          <p:cNvCxnSpPr>
+            <a:cxnSpLocks/>
+            <a:stCxn id="9" idx="3"/>
+            <a:endCxn id="11" idx="1"/>
+          </p:cNvCxnSpPr>
+          <p:nvPr/>
+        </p:nvCxnSpPr>
+        <p:spPr>
+          <a:xfrm>
+            <a:off x="4799064" y="3085490"/>
+            <a:ext cx="504386" cy="468055"/>
+          </a:xfrm>
+          <a:prstGeom prst="bentConnector3">
+            <a:avLst>
+              <a:gd name="adj1" fmla="val 50000"/>
+            </a:avLst>
+          </a:prstGeom>
+          <a:ln w="38100">
+            <a:solidFill>
+              <a:schemeClr val="accent3"/>
+            </a:solidFill>
+            <a:tailEnd type="triangle"/>
+          </a:ln>
+        </p:spPr>
+        <p:style>
+          <a:lnRef idx="1">
+            <a:schemeClr val="accent1"/>
+          </a:lnRef>
+          <a:fillRef idx="0">
+            <a:schemeClr val="accent1"/>
+          </a:fillRef>
+          <a:effectRef idx="0">
+            <a:schemeClr val="accent1"/>
+          </a:effectRef>
+          <a:fontRef idx="minor">
+            <a:schemeClr val="tx1"/>
+          </a:fontRef>
+        </p:style>
+      </p:cxnSp>
+      <p:cxnSp>
+        <p:nvCxnSpPr>
+          <p:cNvPr id="46" name="Connector: Elbow 45">
+            <a:extLst>
+              <a:ext uri="{FF2B5EF4-FFF2-40B4-BE49-F238E27FC236}">
+                <a16:creationId xmlns:a16="http://schemas.microsoft.com/office/drawing/2014/main" id="{02B63221-1800-0B55-8746-BED01C6CD62E}"/>
+              </a:ext>
+            </a:extLst>
+          </p:cNvPr>
+          <p:cNvCxnSpPr>
+            <a:cxnSpLocks/>
+            <a:stCxn id="12" idx="3"/>
+            <a:endCxn id="11" idx="1"/>
+          </p:cNvCxnSpPr>
+          <p:nvPr/>
+        </p:nvCxnSpPr>
+        <p:spPr>
+          <a:xfrm flipV="1">
+            <a:off x="4799054" y="3553545"/>
+            <a:ext cx="504396" cy="401235"/>
+          </a:xfrm>
+          <a:prstGeom prst="bentConnector3">
+            <a:avLst>
+              <a:gd name="adj1" fmla="val 50000"/>
+            </a:avLst>
+          </a:prstGeom>
+          <a:ln w="38100">
+            <a:solidFill>
+              <a:schemeClr val="accent3"/>
+            </a:solidFill>
+            <a:tailEnd type="triangle"/>
+          </a:ln>
+        </p:spPr>
+        <p:style>
+          <a:lnRef idx="1">
+            <a:schemeClr val="accent1"/>
+          </a:lnRef>
+          <a:fillRef idx="0">
+            <a:schemeClr val="accent1"/>
+          </a:fillRef>
+          <a:effectRef idx="0">
+            <a:schemeClr val="accent1"/>
+          </a:effectRef>
+          <a:fontRef idx="minor">
+            <a:schemeClr val="tx1"/>
+          </a:fontRef>
+        </p:style>
+      </p:cxnSp>
+      <p:cxnSp>
+        <p:nvCxnSpPr>
+          <p:cNvPr id="49" name="Straight Arrow Connector 48">
+            <a:extLst>
+              <a:ext uri="{FF2B5EF4-FFF2-40B4-BE49-F238E27FC236}">
+                <a16:creationId xmlns:a16="http://schemas.microsoft.com/office/drawing/2014/main" id="{5A290D47-E450-0156-4467-FB93C3507381}"/>
+              </a:ext>
+            </a:extLst>
+          </p:cNvPr>
+          <p:cNvCxnSpPr>
+            <a:cxnSpLocks/>
+            <a:stCxn id="11" idx="3"/>
+            <a:endCxn id="6" idx="1"/>
+          </p:cNvCxnSpPr>
+          <p:nvPr/>
+        </p:nvCxnSpPr>
+        <p:spPr>
+          <a:xfrm flipV="1">
+            <a:off x="6677489" y="3553544"/>
+            <a:ext cx="504374" cy="1"/>
+          </a:xfrm>
+          <a:prstGeom prst="straightConnector1">
+            <a:avLst/>
+          </a:prstGeom>
+          <a:ln w="38100">
+            <a:solidFill>
+              <a:schemeClr val="accent3"/>
+            </a:solidFill>
+            <a:tailEnd type="triangle"/>
+          </a:ln>
+        </p:spPr>
+        <p:style>
+          <a:lnRef idx="1">
+            <a:schemeClr val="accent1"/>
+          </a:lnRef>
+          <a:fillRef idx="0">
+            <a:schemeClr val="accent1"/>
+          </a:fillRef>
+          <a:effectRef idx="0">
+            <a:schemeClr val="accent1"/>
+          </a:effectRef>
+          <a:fontRef idx="minor">
+            <a:schemeClr val="tx1"/>
+          </a:fontRef>
+        </p:style>
+      </p:cxnSp>
+      <p:cxnSp>
+        <p:nvCxnSpPr>
+          <p:cNvPr id="5" name="Connector: Elbow 4">
+            <a:extLst>
+              <a:ext uri="{FF2B5EF4-FFF2-40B4-BE49-F238E27FC236}">
+                <a16:creationId xmlns:a16="http://schemas.microsoft.com/office/drawing/2014/main" id="{3675E32C-D33B-12F7-6EEB-D78007B65AD9}"/>
+              </a:ext>
+            </a:extLst>
+          </p:cNvPr>
+          <p:cNvCxnSpPr>
+            <a:cxnSpLocks/>
+          </p:cNvCxnSpPr>
+          <p:nvPr/>
+        </p:nvCxnSpPr>
+        <p:spPr>
+          <a:xfrm flipH="1" flipV="1">
+            <a:off x="1441059" y="3495819"/>
+            <a:ext cx="9098819" cy="17474"/>
+          </a:xfrm>
+          <a:prstGeom prst="bentConnector5">
+            <a:avLst>
+              <a:gd name="adj1" fmla="val -4016"/>
+              <a:gd name="adj2" fmla="val -13441942"/>
+              <a:gd name="adj3" fmla="val 105092"/>
+            </a:avLst>
+          </a:prstGeom>
+          <a:ln w="38100">
+            <a:solidFill>
+              <a:schemeClr val="accent3"/>
+            </a:solidFill>
+            <a:tailEnd type="triangle"/>
+          </a:ln>
+        </p:spPr>
+        <p:style>
+          <a:lnRef idx="1">
+            <a:schemeClr val="accent1"/>
+          </a:lnRef>
+          <a:fillRef idx="0">
+            <a:schemeClr val="accent1"/>
+          </a:fillRef>
+          <a:effectRef idx="0">
+            <a:schemeClr val="accent1"/>
+          </a:effectRef>
+          <a:fontRef idx="minor">
+            <a:schemeClr val="tx1"/>
+          </a:fontRef>
+        </p:style>
+      </p:cxnSp>
+    </p:spTree>
+    <p:extLst>
+      <p:ext uri="{BB962C8B-B14F-4D97-AF65-F5344CB8AC3E}">
+        <p14:creationId xmlns:p14="http://schemas.microsoft.com/office/powerpoint/2010/main" val="4003598544"/>
+      </p:ext>
+    </p:extLst>
+  </p:cSld>
+  <p:clrMapOvr>
+    <a:masterClrMapping/>
+  </p:clrMapOvr>
+</p:sld>
+</file>
+
 <file path=ppt/theme/theme1.xml><?xml version="1.0" encoding="utf-8"?>
 <a:theme xmlns:a="http://schemas.openxmlformats.org/drawingml/2006/main" name="Office 2013 - 2022 Theme">
   <a:themeElements>

</xml_diff>